<commit_message>
Update final internship presentation
</commit_message>
<xml_diff>
--- a/Final Project/EduVision_Presentation.pptx
+++ b/Final Project/EduVision_Presentation.pptx
@@ -18,9 +18,13 @@
     <p:sldId id="263" r:id="rId9"/>
     <p:sldId id="264" r:id="rId10"/>
     <p:sldId id="265" r:id="rId11"/>
+    <p:sldId id="278" r:id="rId24"/>
     <p:sldId id="267" r:id="rId12"/>
     <p:sldId id="268" r:id="rId13"/>
+    <p:sldId id="279" r:id="rId25"/>
+    <p:sldId id="280" r:id="rId26"/>
     <p:sldId id="271" r:id="rId14"/>
+    <p:sldId id="281" r:id="rId27"/>
     <p:sldId id="273" r:id="rId15"/>
     <p:sldId id="274" r:id="rId16"/>
     <p:sldId id="275" r:id="rId17"/>
@@ -2200,6 +2204,10 @@
           </a:solidFill>
           <a:ln/>
         </p:spPr>
+        <p:txBody>
+          <a:bodyPr/>
+          <a:p/>
+        </p:txBody>
       </p:sp>
       <p:sp>
         <p:nvSpPr>
@@ -2220,6 +2228,10 @@
           </a:solidFill>
           <a:ln/>
         </p:spPr>
+        <p:txBody>
+          <a:bodyPr/>
+          <a:p/>
+        </p:txBody>
       </p:sp>
       <p:sp>
         <p:nvSpPr>
@@ -2364,6 +2376,10 @@
             <a:prstDash val="solid"/>
           </a:ln>
         </p:spPr>
+        <p:txBody>
+          <a:bodyPr/>
+          <a:p/>
+        </p:txBody>
       </p:sp>
       <p:sp>
         <p:nvSpPr>
@@ -2469,6 +2485,10 @@
             <a:prstDash val="solid"/>
           </a:ln>
         </p:spPr>
+        <p:txBody>
+          <a:bodyPr/>
+          <a:p/>
+        </p:txBody>
       </p:sp>
       <p:sp>
         <p:nvSpPr>
@@ -2574,6 +2594,10 @@
             <a:prstDash val="solid"/>
           </a:ln>
         </p:spPr>
+        <p:txBody>
+          <a:bodyPr/>
+          <a:p/>
+        </p:txBody>
       </p:sp>
       <p:sp>
         <p:nvSpPr>
@@ -2795,6 +2819,10 @@
           </a:solidFill>
           <a:ln/>
         </p:spPr>
+        <p:txBody>
+          <a:bodyPr/>
+          <a:p/>
+        </p:txBody>
       </p:sp>
       <p:sp>
         <p:nvSpPr>
@@ -2815,6 +2843,10 @@
           </a:solidFill>
           <a:ln/>
         </p:spPr>
+        <p:txBody>
+          <a:bodyPr/>
+          <a:p/>
+        </p:txBody>
       </p:sp>
       <p:sp>
         <p:nvSpPr>
@@ -2888,7 +2920,7 @@
                 <a:ea typeface="Arial" pitchFamily="34" charset="-122"/>
                 <a:cs typeface="Arial" pitchFamily="34" charset="-120"/>
               </a:rPr>
-              <a:t>11</a:t>
+              <a:t>12</a:t>
             </a:r>
             <a:endParaRPr lang="en-US" sz="1000" dirty="0"/>
           </a:p>
@@ -3060,6 +3092,10 @@
           </a:solidFill>
           <a:ln/>
         </p:spPr>
+        <p:txBody>
+          <a:bodyPr/>
+          <a:p/>
+        </p:txBody>
       </p:sp>
       <p:sp>
         <p:nvSpPr>
@@ -3211,6 +3247,10 @@
           </a:solidFill>
           <a:ln/>
         </p:spPr>
+        <p:txBody>
+          <a:bodyPr/>
+          <a:p/>
+        </p:txBody>
       </p:sp>
       <p:sp>
         <p:nvSpPr>
@@ -3231,6 +3271,10 @@
           </a:solidFill>
           <a:ln/>
         </p:spPr>
+        <p:txBody>
+          <a:bodyPr/>
+          <a:p/>
+        </p:txBody>
       </p:sp>
       <p:sp>
         <p:nvSpPr>
@@ -3304,7 +3348,7 @@
                 <a:ea typeface="Arial" pitchFamily="34" charset="-122"/>
                 <a:cs typeface="Arial" pitchFamily="34" charset="-120"/>
               </a:rPr>
-              <a:t>12</a:t>
+              <a:t>13</a:t>
             </a:r>
             <a:endParaRPr lang="en-US" sz="1000" dirty="0"/>
           </a:p>
@@ -3377,6 +3421,10 @@
             </a:outerShdw>
           </a:effectLst>
         </p:spPr>
+        <p:txBody>
+          <a:bodyPr/>
+          <a:p/>
+        </p:txBody>
       </p:sp>
       <p:sp>
         <p:nvSpPr>
@@ -3484,6 +3532,10 @@
             </a:outerShdw>
           </a:effectLst>
         </p:spPr>
+        <p:txBody>
+          <a:bodyPr/>
+          <a:p/>
+        </p:txBody>
       </p:sp>
       <p:sp>
         <p:nvSpPr>
@@ -3591,6 +3643,10 @@
             </a:outerShdw>
           </a:effectLst>
         </p:spPr>
+        <p:txBody>
+          <a:bodyPr/>
+          <a:p/>
+        </p:txBody>
       </p:sp>
       <p:sp>
         <p:nvSpPr>
@@ -3698,6 +3754,10 @@
             </a:outerShdw>
           </a:effectLst>
         </p:spPr>
+        <p:txBody>
+          <a:bodyPr/>
+          <a:p/>
+        </p:txBody>
       </p:sp>
       <p:sp>
         <p:nvSpPr>
@@ -3805,6 +3865,10 @@
             </a:outerShdw>
           </a:effectLst>
         </p:spPr>
+        <p:txBody>
+          <a:bodyPr/>
+          <a:p/>
+        </p:txBody>
       </p:sp>
       <p:sp>
         <p:nvSpPr>
@@ -3912,6 +3976,10 @@
             </a:outerShdw>
           </a:effectLst>
         </p:spPr>
+        <p:txBody>
+          <a:bodyPr/>
+          <a:p/>
+        </p:txBody>
       </p:sp>
       <p:sp>
         <p:nvSpPr>
@@ -4048,6 +4116,10 @@
           </a:solidFill>
           <a:ln/>
         </p:spPr>
+        <p:txBody>
+          <a:bodyPr/>
+          <a:p/>
+        </p:txBody>
       </p:sp>
       <p:sp>
         <p:nvSpPr>
@@ -4068,6 +4140,10 @@
           </a:solidFill>
           <a:ln/>
         </p:spPr>
+        <p:txBody>
+          <a:bodyPr/>
+          <a:p/>
+        </p:txBody>
       </p:sp>
       <p:sp>
         <p:nvSpPr>
@@ -4141,7 +4217,7 @@
                 <a:ea typeface="Arial" pitchFamily="34" charset="-122"/>
                 <a:cs typeface="Arial" pitchFamily="34" charset="-120"/>
               </a:rPr>
-              <a:t>13</a:t>
+              <a:t>16</a:t>
             </a:r>
             <a:endParaRPr lang="en-US" sz="1000" dirty="0"/>
           </a:p>
@@ -4207,6 +4283,10 @@
           </a:solidFill>
           <a:ln/>
         </p:spPr>
+        <p:txBody>
+          <a:bodyPr/>
+          <a:p/>
+        </p:txBody>
       </p:sp>
       <p:sp>
         <p:nvSpPr>
@@ -4307,6 +4387,10 @@
           </a:solidFill>
           <a:ln/>
         </p:spPr>
+        <p:txBody>
+          <a:bodyPr/>
+          <a:p/>
+        </p:txBody>
       </p:sp>
       <p:sp>
         <p:nvSpPr>
@@ -4407,6 +4491,10 @@
           </a:solidFill>
           <a:ln/>
         </p:spPr>
+        <p:txBody>
+          <a:bodyPr/>
+          <a:p/>
+        </p:txBody>
       </p:sp>
       <p:sp>
         <p:nvSpPr>
@@ -4507,6 +4595,10 @@
           </a:solidFill>
           <a:ln/>
         </p:spPr>
+        <p:txBody>
+          <a:bodyPr/>
+          <a:p/>
+        </p:txBody>
       </p:sp>
       <p:sp>
         <p:nvSpPr>
@@ -4568,6 +4660,10 @@
           </a:solidFill>
           <a:ln/>
         </p:spPr>
+        <p:txBody>
+          <a:bodyPr/>
+          <a:p/>
+        </p:txBody>
       </p:sp>
       <p:sp>
         <p:nvSpPr>
@@ -4665,6 +4761,10 @@
           </a:solidFill>
           <a:ln/>
         </p:spPr>
+        <p:txBody>
+          <a:bodyPr/>
+          <a:p/>
+        </p:txBody>
       </p:sp>
       <p:sp>
         <p:nvSpPr>
@@ -4685,6 +4785,10 @@
           </a:solidFill>
           <a:ln/>
         </p:spPr>
+        <p:txBody>
+          <a:bodyPr/>
+          <a:p/>
+        </p:txBody>
       </p:sp>
       <p:sp>
         <p:nvSpPr>
@@ -4758,7 +4862,7 @@
                 <a:ea typeface="Arial" pitchFamily="34" charset="-122"/>
                 <a:cs typeface="Arial" pitchFamily="34" charset="-120"/>
               </a:rPr>
-              <a:t>14</a:t>
+              <a:t>18</a:t>
             </a:r>
             <a:endParaRPr lang="en-US" sz="1000" dirty="0"/>
           </a:p>
@@ -5046,6 +5150,10 @@
           </a:solidFill>
           <a:ln/>
         </p:spPr>
+        <p:txBody>
+          <a:bodyPr/>
+          <a:p/>
+        </p:txBody>
       </p:sp>
       <p:sp>
         <p:nvSpPr>
@@ -5066,6 +5174,10 @@
           </a:solidFill>
           <a:ln/>
         </p:spPr>
+        <p:txBody>
+          <a:bodyPr/>
+          <a:p/>
+        </p:txBody>
       </p:sp>
       <p:sp>
         <p:nvSpPr>
@@ -5139,7 +5251,7 @@
                 <a:ea typeface="Arial" pitchFamily="34" charset="-122"/>
                 <a:cs typeface="Arial" pitchFamily="34" charset="-120"/>
               </a:rPr>
-              <a:t>15</a:t>
+              <a:t>19</a:t>
             </a:r>
             <a:endParaRPr lang="en-US" sz="1000" dirty="0"/>
           </a:p>
@@ -5347,6 +5459,10 @@
           </a:solidFill>
           <a:ln/>
         </p:spPr>
+        <p:txBody>
+          <a:bodyPr/>
+          <a:p/>
+        </p:txBody>
       </p:sp>
       <p:sp>
         <p:nvSpPr>
@@ -5367,6 +5483,10 @@
           </a:solidFill>
           <a:ln/>
         </p:spPr>
+        <p:txBody>
+          <a:bodyPr/>
+          <a:p/>
+        </p:txBody>
       </p:sp>
       <p:sp>
         <p:nvSpPr>
@@ -5439,7 +5559,7 @@
                 <a:latin typeface="Arial" pitchFamily="34" charset="0"/>
                 <a:cs typeface="Arial" pitchFamily="34" charset="-120"/>
               </a:rPr>
-              <a:t>16</a:t>
+              <a:t>20</a:t>
             </a:r>
             <a:endParaRPr lang="en-US" sz="1000" dirty="0"/>
           </a:p>
@@ -5512,6 +5632,10 @@
             </a:outerShdw>
           </a:effectLst>
         </p:spPr>
+        <p:txBody>
+          <a:bodyPr/>
+          <a:p/>
+        </p:txBody>
       </p:sp>
       <p:sp>
         <p:nvSpPr>
@@ -5658,6 +5782,10 @@
             </a:outerShdw>
           </a:effectLst>
         </p:spPr>
+        <p:txBody>
+          <a:bodyPr/>
+          <a:p/>
+        </p:txBody>
       </p:sp>
       <p:sp>
         <p:nvSpPr>
@@ -5804,6 +5932,10 @@
             </a:outerShdw>
           </a:effectLst>
         </p:spPr>
+        <p:txBody>
+          <a:bodyPr/>
+          <a:p/>
+        </p:txBody>
       </p:sp>
       <p:sp>
         <p:nvSpPr>
@@ -5950,6 +6082,10 @@
             </a:outerShdw>
           </a:effectLst>
         </p:spPr>
+        <p:txBody>
+          <a:bodyPr/>
+          <a:p/>
+        </p:txBody>
       </p:sp>
       <p:sp>
         <p:nvSpPr>
@@ -6250,6 +6386,10 @@
           </a:solidFill>
           <a:ln/>
         </p:spPr>
+        <p:txBody>
+          <a:bodyPr/>
+          <a:p/>
+        </p:txBody>
       </p:sp>
       <p:sp>
         <p:nvSpPr>
@@ -6359,6 +6499,1429 @@
   </p:clrMapOvr>
   <p:transition spd="med">
     <p:split/>
+  </p:transition>
+</p:sld>
+</file>
+
+<file path=ppt/slides/slide18.xml><?xml version="1.0" encoding="utf-8"?>
+<p:sld xmlns:a="http://schemas.openxmlformats.org/drawingml/2006/main" xmlns:p="http://schemas.openxmlformats.org/presentationml/2006/main" xmlns:r="http://schemas.openxmlformats.org/officeDocument/2006/relationships">
+  <p:cSld>
+    <p:spTree>
+      <p:nvGrpSpPr>
+        <p:cNvPr id="1" name=""/>
+        <p:cNvGrpSpPr/>
+        <p:nvPr/>
+      </p:nvGrpSpPr>
+      <p:grpSpPr/>
+      <p:sp>
+        <p:nvSpPr>
+          <p:cNvPr id="2" name="Shape 0"/>
+          <p:cNvSpPr/>
+          <p:nvPr/>
+        </p:nvSpPr>
+        <p:spPr>
+          <a:xfrm>
+            <a:off x="7863840" y="-822960"/>
+            <a:ext cx="2011680" cy="2011680"/>
+          </a:xfrm>
+          <a:prstGeom prst="ellipse">
+            <a:avLst/>
+          </a:prstGeom>
+          <a:solidFill>
+            <a:srgbClr val="FFB030">
+              <a:alpha val="30000"/>
+            </a:srgbClr>
+          </a:solidFill>
+          <a:ln/>
+        </p:spPr>
+        <p:txBody>
+          <a:bodyPr/>
+          <a:p/>
+        </p:txBody>
+      </p:sp>
+      <p:sp>
+        <p:nvSpPr>
+          <p:cNvPr id="3" name="Shape 1"/>
+          <p:cNvSpPr/>
+          <p:nvPr/>
+        </p:nvSpPr>
+        <p:spPr>
+          <a:xfrm>
+            <a:off x="274320" y="274320"/>
+            <a:ext cx="164592" cy="164592"/>
+          </a:xfrm>
+          <a:prstGeom prst="ellipse">
+            <a:avLst/>
+          </a:prstGeom>
+          <a:solidFill>
+            <a:srgbClr val="E8442F"/>
+          </a:solidFill>
+          <a:ln/>
+        </p:spPr>
+        <p:txBody>
+          <a:bodyPr/>
+          <a:p/>
+        </p:txBody>
+      </p:sp>
+      <p:sp>
+        <p:nvSpPr>
+          <p:cNvPr id="4" name="Text 2"/>
+          <p:cNvSpPr txBox="1"/>
+          <p:nvPr/>
+        </p:nvSpPr>
+        <p:spPr>
+          <a:xfrm>
+            <a:off x="502920" y="201168"/>
+            <a:ext cx="1828800" cy="320040"/>
+          </a:xfrm>
+          <a:prstGeom prst="rect">
+            <a:avLst/>
+          </a:prstGeom>
+          <a:noFill/>
+          <a:ln/>
+        </p:spPr>
+        <p:txBody>
+          <a:bodyPr wrap="square" lIns="0" tIns="0" rIns="0" bIns="0" rtlCol="0" anchor="ctr"/>
+          <a:lstStyle/>
+          <a:p>
+            <a:pPr marL="0" indent="0">
+              <a:buNone/>
+            </a:pPr>
+            <a:r>
+              <a:rPr lang="en-US" sz="1100" b="1" dirty="0">
+                <a:solidFill>
+                  <a:srgbClr val="E8442F"/>
+                </a:solidFill>
+                <a:latin typeface="Arial" pitchFamily="34" charset="0"/>
+                <a:ea typeface="Arial" pitchFamily="34" charset="-122"/>
+                <a:cs typeface="Arial" pitchFamily="34" charset="-120"/>
+              </a:rPr>
+              <a:t>EduVision</a:t>
+            </a:r>
+            <a:endParaRPr lang="en-US" sz="1100" dirty="0"/>
+          </a:p>
+        </p:txBody>
+      </p:sp>
+      <p:sp>
+        <p:nvSpPr>
+          <p:cNvPr id="5" name="Text 3"/>
+          <p:cNvSpPr txBox="1"/>
+          <p:nvPr/>
+        </p:nvSpPr>
+        <p:spPr>
+          <a:xfrm>
+            <a:off x="8138160" y="4709160"/>
+            <a:ext cx="640080" cy="274320"/>
+          </a:xfrm>
+          <a:prstGeom prst="rect">
+            <a:avLst/>
+          </a:prstGeom>
+          <a:noFill/>
+          <a:ln/>
+        </p:spPr>
+        <p:txBody>
+          <a:bodyPr wrap="square" lIns="0" tIns="0" rIns="0" bIns="0" rtlCol="0" anchor="ctr"/>
+          <a:lstStyle/>
+          <a:p>
+            <a:pPr marL="0" indent="0" algn="r">
+              <a:buNone/>
+            </a:pPr>
+            <a:r>
+              <a:rPr lang="en-US" sz="1000" dirty="0">
+                <a:solidFill>
+                  <a:srgbClr val="F47B20"/>
+                </a:solidFill>
+                <a:latin typeface="Arial" pitchFamily="34" charset="0"/>
+                <a:ea typeface="Arial" pitchFamily="34" charset="-122"/>
+                <a:cs typeface="Arial" pitchFamily="34" charset="-120"/>
+              </a:rPr>
+              <a:t>11</a:t>
+            </a:r>
+            <a:endParaRPr lang="en-US" sz="1000" dirty="0"/>
+          </a:p>
+        </p:txBody>
+      </p:sp>
+      <p:sp>
+        <p:nvSpPr>
+          <p:cNvPr id="6" name="Text 4"/>
+          <p:cNvSpPr txBox="1"/>
+          <p:nvPr/>
+        </p:nvSpPr>
+        <p:spPr>
+          <a:xfrm>
+            <a:off x="457200" y="640080"/>
+            <a:ext cx="8229600" cy="640080"/>
+          </a:xfrm>
+          <a:prstGeom prst="rect">
+            <a:avLst/>
+          </a:prstGeom>
+          <a:noFill/>
+          <a:ln/>
+        </p:spPr>
+        <p:txBody>
+          <a:bodyPr wrap="square" lIns="0" tIns="0" rIns="0" bIns="0" rtlCol="0" anchor="ctr"/>
+          <a:lstStyle/>
+          <a:p>
+            <a:pPr marL="0" indent="0">
+              <a:buNone/>
+            </a:pPr>
+            <a:r>
+              <a:rPr lang="en-US" sz="2600" b="1" dirty="0">
+                <a:solidFill>
+                  <a:srgbClr val="E8442F"/>
+                </a:solidFill>
+                <a:latin typeface="Arial" pitchFamily="34" charset="0"/>
+                <a:ea typeface="Arial" pitchFamily="34" charset="-122"/>
+                <a:cs typeface="Arial" pitchFamily="34" charset="-120"/>
+              </a:rPr>
+              <a:t>Analytical Methodology</a:t>
+            </a:r>
+            <a:endParaRPr lang="en-US" sz="2600" dirty="0"/>
+          </a:p>
+        </p:txBody>
+      </p:sp>
+      <p:sp>
+        <p:nvSpPr>
+          <p:cNvPr id="7" name="Shape 5"/>
+          <p:cNvSpPr/>
+          <p:nvPr/>
+        </p:nvSpPr>
+        <p:spPr>
+          <a:xfrm>
+            <a:off x="457200" y="1645920"/>
+            <a:ext cx="1885950" cy="2194560"/>
+          </a:xfrm>
+          <a:prstGeom prst="roundRect">
+            <a:avLst>
+              <a:gd name="adj" fmla="val 5818"/>
+            </a:avLst>
+          </a:prstGeom>
+          <a:solidFill>
+            <a:srgbClr val="E8442F"/>
+          </a:solidFill>
+          <a:ln/>
+          <a:effectLst>
+            <a:outerShdw blurRad="76200" dist="25400" dir="5400000" algn="bl" rotWithShape="0">
+              <a:srgbClr val="000000">
+                <a:alpha val="18000"/>
+              </a:srgbClr>
+            </a:outerShdw>
+          </a:effectLst>
+        </p:spPr>
+        <p:txBody>
+          <a:bodyPr/>
+          <a:p/>
+        </p:txBody>
+      </p:sp>
+      <p:sp>
+        <p:nvSpPr>
+          <p:cNvPr id="8" name="Text 6"/>
+          <p:cNvSpPr txBox="1"/>
+          <p:nvPr/>
+        </p:nvSpPr>
+        <p:spPr>
+          <a:xfrm>
+            <a:off x="640080" y="1783080"/>
+            <a:ext cx="1520190" cy="457200"/>
+          </a:xfrm>
+          <a:prstGeom prst="rect">
+            <a:avLst/>
+          </a:prstGeom>
+          <a:noFill/>
+          <a:ln/>
+        </p:spPr>
+        <p:txBody>
+          <a:bodyPr wrap="square" lIns="0" tIns="0" rIns="0" bIns="0" rtlCol="0" anchor="ctr"/>
+          <a:lstStyle/>
+          <a:p>
+            <a:pPr marL="0" indent="0">
+              <a:buNone/>
+            </a:pPr>
+            <a:r>
+              <a:rPr lang="en-US" sz="2600" b="1" dirty="0">
+                <a:solidFill>
+                  <a:srgbClr val="FFFFFF"/>
+                </a:solidFill>
+                <a:latin typeface="Arial" pitchFamily="34" charset="0"/>
+                <a:ea typeface="Arial" pitchFamily="34" charset="-122"/>
+                <a:cs typeface="Arial" pitchFamily="34" charset="-120"/>
+              </a:rPr>
+              <a:t>01</a:t>
+            </a:r>
+            <a:endParaRPr lang="en-US" sz="2600" dirty="0"/>
+          </a:p>
+        </p:txBody>
+      </p:sp>
+      <p:sp>
+        <p:nvSpPr>
+          <p:cNvPr id="9" name="Text 7"/>
+          <p:cNvSpPr txBox="1"/>
+          <p:nvPr/>
+        </p:nvSpPr>
+        <p:spPr>
+          <a:xfrm>
+            <a:off x="640080" y="2286000"/>
+            <a:ext cx="1520190" cy="457200"/>
+          </a:xfrm>
+          <a:prstGeom prst="rect">
+            <a:avLst/>
+          </a:prstGeom>
+          <a:noFill/>
+          <a:ln/>
+        </p:spPr>
+        <p:txBody>
+          <a:bodyPr wrap="square" lIns="0" tIns="0" rIns="0" bIns="0" rtlCol="0" anchor="t"/>
+          <a:lstStyle/>
+          <a:p>
+            <a:pPr marL="0" indent="0">
+              <a:buNone/>
+            </a:pPr>
+            <a:r>
+              <a:rPr lang="en-US" sz="1400" b="1" dirty="0">
+                <a:solidFill>
+                  <a:srgbClr val="FFFFFF"/>
+                </a:solidFill>
+                <a:latin typeface="Arial" pitchFamily="34" charset="0"/>
+                <a:ea typeface="Arial" pitchFamily="34" charset="-122"/>
+                <a:cs typeface="Arial" pitchFamily="34" charset="-120"/>
+              </a:rPr>
+              <a:t>University-Level</a:t>
+            </a:r>
+            <a:endParaRPr lang="en-US" sz="1400" dirty="0"/>
+          </a:p>
+        </p:txBody>
+      </p:sp>
+      <p:sp>
+        <p:nvSpPr>
+          <p:cNvPr id="10" name="Text 8"/>
+          <p:cNvSpPr txBox="1"/>
+          <p:nvPr/>
+        </p:nvSpPr>
+        <p:spPr>
+          <a:xfrm>
+            <a:off x="640080" y="2788920"/>
+            <a:ext cx="1520190" cy="914400"/>
+          </a:xfrm>
+          <a:prstGeom prst="rect">
+            <a:avLst/>
+          </a:prstGeom>
+          <a:noFill/>
+          <a:ln/>
+        </p:spPr>
+        <p:txBody>
+          <a:bodyPr wrap="square" lIns="0" tIns="0" rIns="0" bIns="0" rtlCol="0" anchor="t"/>
+          <a:lstStyle/>
+          <a:p>
+            <a:pPr marL="0" indent="0">
+              <a:buNone/>
+            </a:pPr>
+            <a:r>
+              <a:rPr lang="en-US" sz="1150" dirty="0">
+                <a:solidFill>
+                  <a:srgbClr val="FFFFFF"/>
+                </a:solidFill>
+                <a:latin typeface="Arial" pitchFamily="34" charset="0"/>
+                <a:ea typeface="Arial" pitchFamily="34" charset="-122"/>
+                <a:cs typeface="Arial" pitchFamily="34" charset="-120"/>
+              </a:rPr>
+              <a:t>Ranking, reputation, research impact, students per staff.</a:t>
+            </a:r>
+            <a:endParaRPr lang="en-US" sz="1150" dirty="0"/>
+          </a:p>
+        </p:txBody>
+      </p:sp>
+      <p:sp>
+        <p:nvSpPr>
+          <p:cNvPr id="11" name="Shape 9"/>
+          <p:cNvSpPr/>
+          <p:nvPr/>
+        </p:nvSpPr>
+        <p:spPr>
+          <a:xfrm>
+            <a:off x="2571750" y="1645920"/>
+            <a:ext cx="1885950" cy="2194560"/>
+          </a:xfrm>
+          <a:prstGeom prst="roundRect">
+            <a:avLst>
+              <a:gd name="adj" fmla="val 5818"/>
+            </a:avLst>
+          </a:prstGeom>
+          <a:solidFill>
+            <a:srgbClr val="F47B20"/>
+          </a:solidFill>
+          <a:ln/>
+          <a:effectLst>
+            <a:outerShdw blurRad="76200" dist="25400" dir="5400000" algn="bl" rotWithShape="0">
+              <a:srgbClr val="000000">
+                <a:alpha val="18000"/>
+              </a:srgbClr>
+            </a:outerShdw>
+          </a:effectLst>
+        </p:spPr>
+        <p:txBody>
+          <a:bodyPr/>
+          <a:p/>
+        </p:txBody>
+      </p:sp>
+      <p:sp>
+        <p:nvSpPr>
+          <p:cNvPr id="12" name="Text 10"/>
+          <p:cNvSpPr txBox="1"/>
+          <p:nvPr/>
+        </p:nvSpPr>
+        <p:spPr>
+          <a:xfrm>
+            <a:off x="2754630" y="1783080"/>
+            <a:ext cx="1520190" cy="457200"/>
+          </a:xfrm>
+          <a:prstGeom prst="rect">
+            <a:avLst/>
+          </a:prstGeom>
+          <a:noFill/>
+          <a:ln/>
+        </p:spPr>
+        <p:txBody>
+          <a:bodyPr wrap="square" lIns="0" tIns="0" rIns="0" bIns="0" rtlCol="0" anchor="ctr"/>
+          <a:lstStyle/>
+          <a:p>
+            <a:pPr marL="0" indent="0">
+              <a:buNone/>
+            </a:pPr>
+            <a:r>
+              <a:rPr lang="en-US" sz="2600" b="1" dirty="0">
+                <a:solidFill>
+                  <a:srgbClr val="FFFFFF"/>
+                </a:solidFill>
+                <a:latin typeface="Arial" pitchFamily="34" charset="0"/>
+                <a:ea typeface="Arial" pitchFamily="34" charset="-122"/>
+                <a:cs typeface="Arial" pitchFamily="34" charset="-120"/>
+              </a:rPr>
+              <a:t>02</a:t>
+            </a:r>
+            <a:endParaRPr lang="en-US" sz="2600" dirty="0"/>
+          </a:p>
+        </p:txBody>
+      </p:sp>
+      <p:sp>
+        <p:nvSpPr>
+          <p:cNvPr id="13" name="Text 11"/>
+          <p:cNvSpPr txBox="1"/>
+          <p:nvPr/>
+        </p:nvSpPr>
+        <p:spPr>
+          <a:xfrm>
+            <a:off x="2754630" y="2286000"/>
+            <a:ext cx="1520190" cy="457200"/>
+          </a:xfrm>
+          <a:prstGeom prst="rect">
+            <a:avLst/>
+          </a:prstGeom>
+          <a:noFill/>
+          <a:ln/>
+        </p:spPr>
+        <p:txBody>
+          <a:bodyPr wrap="square" lIns="0" tIns="0" rIns="0" bIns="0" rtlCol="0" anchor="t"/>
+          <a:lstStyle/>
+          <a:p>
+            <a:pPr marL="0" indent="0">
+              <a:buNone/>
+            </a:pPr>
+            <a:r>
+              <a:rPr lang="en-US" sz="1400" b="1" dirty="0">
+                <a:solidFill>
+                  <a:srgbClr val="FFFFFF"/>
+                </a:solidFill>
+                <a:latin typeface="Arial" pitchFamily="34" charset="0"/>
+                <a:ea typeface="Arial" pitchFamily="34" charset="-122"/>
+                <a:cs typeface="Arial" pitchFamily="34" charset="-120"/>
+              </a:rPr>
+              <a:t>Research Analytics</a:t>
+            </a:r>
+            <a:endParaRPr lang="en-US" sz="1400" dirty="0"/>
+          </a:p>
+        </p:txBody>
+      </p:sp>
+      <p:sp>
+        <p:nvSpPr>
+          <p:cNvPr id="14" name="Text 12"/>
+          <p:cNvSpPr txBox="1"/>
+          <p:nvPr/>
+        </p:nvSpPr>
+        <p:spPr>
+          <a:xfrm>
+            <a:off x="2754630" y="2788920"/>
+            <a:ext cx="1520190" cy="914400"/>
+          </a:xfrm>
+          <a:prstGeom prst="rect">
+            <a:avLst/>
+          </a:prstGeom>
+          <a:noFill/>
+          <a:ln/>
+        </p:spPr>
+        <p:txBody>
+          <a:bodyPr wrap="square" lIns="0" tIns="0" rIns="0" bIns="0" rtlCol="0" anchor="t"/>
+          <a:lstStyle/>
+          <a:p>
+            <a:pPr marL="0" indent="0">
+              <a:buNone/>
+            </a:pPr>
+            <a:r>
+              <a:rPr lang="en-US" sz="1150" dirty="0">
+                <a:solidFill>
+                  <a:srgbClr val="FFFFFF"/>
+                </a:solidFill>
+                <a:latin typeface="Arial" pitchFamily="34" charset="0"/>
+                <a:ea typeface="Arial" pitchFamily="34" charset="-122"/>
+                <a:cs typeface="Arial" pitchFamily="34" charset="-120"/>
+              </a:rPr>
+              <a:t>Citations per faculty, research and citation scores, RPI.</a:t>
+            </a:r>
+            <a:endParaRPr lang="en-US" sz="1150" dirty="0"/>
+          </a:p>
+        </p:txBody>
+      </p:sp>
+      <p:sp>
+        <p:nvSpPr>
+          <p:cNvPr id="15" name="Shape 13"/>
+          <p:cNvSpPr/>
+          <p:nvPr/>
+        </p:nvSpPr>
+        <p:spPr>
+          <a:xfrm>
+            <a:off x="4686300" y="1645920"/>
+            <a:ext cx="1885950" cy="2194560"/>
+          </a:xfrm>
+          <a:prstGeom prst="roundRect">
+            <a:avLst>
+              <a:gd name="adj" fmla="val 5818"/>
+            </a:avLst>
+          </a:prstGeom>
+          <a:solidFill>
+            <a:srgbClr val="D9365E"/>
+          </a:solidFill>
+          <a:ln/>
+          <a:effectLst>
+            <a:outerShdw blurRad="76200" dist="25400" dir="5400000" algn="bl" rotWithShape="0">
+              <a:srgbClr val="000000">
+                <a:alpha val="18000"/>
+              </a:srgbClr>
+            </a:outerShdw>
+          </a:effectLst>
+        </p:spPr>
+        <p:txBody>
+          <a:bodyPr/>
+          <a:p/>
+        </p:txBody>
+      </p:sp>
+      <p:sp>
+        <p:nvSpPr>
+          <p:cNvPr id="16" name="Text 14"/>
+          <p:cNvSpPr txBox="1"/>
+          <p:nvPr/>
+        </p:nvSpPr>
+        <p:spPr>
+          <a:xfrm>
+            <a:off x="4869180" y="1783080"/>
+            <a:ext cx="1520190" cy="457200"/>
+          </a:xfrm>
+          <a:prstGeom prst="rect">
+            <a:avLst/>
+          </a:prstGeom>
+          <a:noFill/>
+          <a:ln/>
+        </p:spPr>
+        <p:txBody>
+          <a:bodyPr wrap="square" lIns="0" tIns="0" rIns="0" bIns="0" rtlCol="0" anchor="ctr"/>
+          <a:lstStyle/>
+          <a:p>
+            <a:pPr marL="0" indent="0">
+              <a:buNone/>
+            </a:pPr>
+            <a:r>
+              <a:rPr lang="en-US" sz="2600" b="1" dirty="0">
+                <a:solidFill>
+                  <a:srgbClr val="FFFFFF"/>
+                </a:solidFill>
+                <a:latin typeface="Arial" pitchFamily="34" charset="0"/>
+                <a:ea typeface="Arial" pitchFamily="34" charset="-122"/>
+                <a:cs typeface="Arial" pitchFamily="34" charset="-120"/>
+              </a:rPr>
+              <a:t>03</a:t>
+            </a:r>
+            <a:endParaRPr lang="en-US" sz="2600" dirty="0"/>
+          </a:p>
+        </p:txBody>
+      </p:sp>
+      <p:sp>
+        <p:nvSpPr>
+          <p:cNvPr id="17" name="Text 15"/>
+          <p:cNvSpPr txBox="1"/>
+          <p:nvPr/>
+        </p:nvSpPr>
+        <p:spPr>
+          <a:xfrm>
+            <a:off x="4869180" y="2286000"/>
+            <a:ext cx="1520190" cy="457200"/>
+          </a:xfrm>
+          <a:prstGeom prst="rect">
+            <a:avLst/>
+          </a:prstGeom>
+          <a:noFill/>
+          <a:ln/>
+        </p:spPr>
+        <p:txBody>
+          <a:bodyPr wrap="square" lIns="0" tIns="0" rIns="0" bIns="0" rtlCol="0" anchor="t"/>
+          <a:lstStyle/>
+          <a:p>
+            <a:pPr marL="0" indent="0">
+              <a:buNone/>
+            </a:pPr>
+            <a:r>
+              <a:rPr lang="en-US" sz="1400" b="1" dirty="0">
+                <a:solidFill>
+                  <a:srgbClr val="FFFFFF"/>
+                </a:solidFill>
+                <a:latin typeface="Arial" pitchFamily="34" charset="0"/>
+                <a:ea typeface="Arial" pitchFamily="34" charset="-122"/>
+                <a:cs typeface="Arial" pitchFamily="34" charset="-120"/>
+              </a:rPr>
+              <a:t>Student Analytics</a:t>
+            </a:r>
+            <a:endParaRPr lang="en-US" sz="1400" dirty="0"/>
+          </a:p>
+        </p:txBody>
+      </p:sp>
+      <p:sp>
+        <p:nvSpPr>
+          <p:cNvPr id="18" name="Text 16"/>
+          <p:cNvSpPr txBox="1"/>
+          <p:nvPr/>
+        </p:nvSpPr>
+        <p:spPr>
+          <a:xfrm>
+            <a:off x="4869180" y="2788920"/>
+            <a:ext cx="1520190" cy="914400"/>
+          </a:xfrm>
+          <a:prstGeom prst="rect">
+            <a:avLst/>
+          </a:prstGeom>
+          <a:noFill/>
+          <a:ln/>
+        </p:spPr>
+        <p:txBody>
+          <a:bodyPr wrap="square" lIns="0" tIns="0" rIns="0" bIns="0" rtlCol="0" anchor="t"/>
+          <a:lstStyle/>
+          <a:p>
+            <a:pPr marL="0" indent="0">
+              <a:buNone/>
+            </a:pPr>
+            <a:r>
+              <a:rPr lang="en-US" sz="1150" dirty="0">
+                <a:solidFill>
+                  <a:srgbClr val="FFFFFF"/>
+                </a:solidFill>
+                <a:latin typeface="Arial" pitchFamily="34" charset="0"/>
+                <a:ea typeface="Arial" pitchFamily="34" charset="-122"/>
+                <a:cs typeface="Arial" pitchFamily="34" charset="-120"/>
+              </a:rPr>
+              <a:t>International %, faculty-to-student ratio score.</a:t>
+            </a:r>
+            <a:endParaRPr lang="en-US" sz="1150" dirty="0"/>
+          </a:p>
+        </p:txBody>
+      </p:sp>
+      <p:sp>
+        <p:nvSpPr>
+          <p:cNvPr id="19" name="Shape 17"/>
+          <p:cNvSpPr/>
+          <p:nvPr/>
+        </p:nvSpPr>
+        <p:spPr>
+          <a:xfrm>
+            <a:off x="6800850" y="1645920"/>
+            <a:ext cx="1885950" cy="2194560"/>
+          </a:xfrm>
+          <a:prstGeom prst="roundRect">
+            <a:avLst>
+              <a:gd name="adj" fmla="val 5818"/>
+            </a:avLst>
+          </a:prstGeom>
+          <a:solidFill>
+            <a:srgbClr val="FFB030"/>
+          </a:solidFill>
+          <a:ln/>
+          <a:effectLst>
+            <a:outerShdw blurRad="76200" dist="25400" dir="5400000" algn="bl" rotWithShape="0">
+              <a:srgbClr val="000000">
+                <a:alpha val="18000"/>
+              </a:srgbClr>
+            </a:outerShdw>
+          </a:effectLst>
+        </p:spPr>
+        <p:txBody>
+          <a:bodyPr/>
+          <a:p/>
+        </p:txBody>
+      </p:sp>
+      <p:sp>
+        <p:nvSpPr>
+          <p:cNvPr id="20" name="Text 18"/>
+          <p:cNvSpPr txBox="1"/>
+          <p:nvPr/>
+        </p:nvSpPr>
+        <p:spPr>
+          <a:xfrm>
+            <a:off x="6983730" y="1783080"/>
+            <a:ext cx="1520190" cy="457200"/>
+          </a:xfrm>
+          <a:prstGeom prst="rect">
+            <a:avLst/>
+          </a:prstGeom>
+          <a:noFill/>
+          <a:ln/>
+        </p:spPr>
+        <p:txBody>
+          <a:bodyPr wrap="square" lIns="0" tIns="0" rIns="0" bIns="0" rtlCol="0" anchor="ctr"/>
+          <a:lstStyle/>
+          <a:p>
+            <a:pPr marL="0" indent="0">
+              <a:buNone/>
+            </a:pPr>
+            <a:r>
+              <a:rPr lang="en-US" sz="2600" b="1" dirty="0">
+                <a:solidFill>
+                  <a:srgbClr val="FFFFFF"/>
+                </a:solidFill>
+                <a:latin typeface="Arial" pitchFamily="34" charset="0"/>
+                <a:ea typeface="Arial" pitchFamily="34" charset="-122"/>
+                <a:cs typeface="Arial" pitchFamily="34" charset="-120"/>
+              </a:rPr>
+              <a:t>04</a:t>
+            </a:r>
+            <a:endParaRPr lang="en-US" sz="2600" dirty="0"/>
+          </a:p>
+        </p:txBody>
+      </p:sp>
+      <p:sp>
+        <p:nvSpPr>
+          <p:cNvPr id="21" name="Text 19"/>
+          <p:cNvSpPr txBox="1"/>
+          <p:nvPr/>
+        </p:nvSpPr>
+        <p:spPr>
+          <a:xfrm>
+            <a:off x="6983730" y="2286000"/>
+            <a:ext cx="1520190" cy="457200"/>
+          </a:xfrm>
+          <a:prstGeom prst="rect">
+            <a:avLst/>
+          </a:prstGeom>
+          <a:noFill/>
+          <a:ln/>
+        </p:spPr>
+        <p:txBody>
+          <a:bodyPr wrap="square" lIns="0" tIns="0" rIns="0" bIns="0" rtlCol="0" anchor="t"/>
+          <a:lstStyle/>
+          <a:p>
+            <a:pPr marL="0" indent="0">
+              <a:buNone/>
+            </a:pPr>
+            <a:r>
+              <a:rPr lang="en-US" sz="1400" b="1" dirty="0">
+                <a:solidFill>
+                  <a:srgbClr val="FFFFFF"/>
+                </a:solidFill>
+                <a:latin typeface="Arial" pitchFamily="34" charset="0"/>
+                <a:ea typeface="Arial" pitchFamily="34" charset="-122"/>
+                <a:cs typeface="Arial" pitchFamily="34" charset="-120"/>
+              </a:rPr>
+              <a:t>Country Level</a:t>
+            </a:r>
+            <a:endParaRPr lang="en-US" sz="1400" dirty="0"/>
+          </a:p>
+        </p:txBody>
+      </p:sp>
+      <p:sp>
+        <p:nvSpPr>
+          <p:cNvPr id="22" name="Text 20"/>
+          <p:cNvSpPr txBox="1"/>
+          <p:nvPr/>
+        </p:nvSpPr>
+        <p:spPr>
+          <a:xfrm>
+            <a:off x="6983730" y="2788920"/>
+            <a:ext cx="1520190" cy="914400"/>
+          </a:xfrm>
+          <a:prstGeom prst="rect">
+            <a:avLst/>
+          </a:prstGeom>
+          <a:noFill/>
+          <a:ln/>
+        </p:spPr>
+        <p:txBody>
+          <a:bodyPr wrap="square" lIns="0" tIns="0" rIns="0" bIns="0" rtlCol="0" anchor="t"/>
+          <a:lstStyle/>
+          <a:p>
+            <a:pPr marL="0" indent="0">
+              <a:buNone/>
+            </a:pPr>
+            <a:r>
+              <a:rPr lang="en-US" sz="1150" dirty="0">
+                <a:solidFill>
+                  <a:srgbClr val="FFFFFF"/>
+                </a:solidFill>
+                <a:latin typeface="Arial" pitchFamily="34" charset="0"/>
+                <a:ea typeface="Arial" pitchFamily="34" charset="-122"/>
+                <a:cs typeface="Arial" pitchFamily="34" charset="-120"/>
+              </a:rPr>
+              <a:t>World Bank indicators and regional comparison.</a:t>
+            </a:r>
+            <a:endParaRPr lang="en-US" sz="1150" dirty="0"/>
+          </a:p>
+        </p:txBody>
+      </p:sp>
+      <p:sp>
+        <p:nvSpPr>
+          <p:cNvPr id="21" name="Shape 19"/>
+          <p:cNvSpPr/>
+          <p:nvPr/>
+        </p:nvSpPr>
+        <p:spPr>
+          <a:xfrm>
+            <a:off x="457200" y="4069080"/>
+            <a:ext cx="8229600" cy="685800"/>
+          </a:xfrm>
+          <a:prstGeom prst="roundRect">
+            <a:avLst>
+              <a:gd name="adj" fmla="val 13333"/>
+            </a:avLst>
+          </a:prstGeom>
+          <a:solidFill>
+            <a:srgbClr val="FFF1E8"/>
+          </a:solidFill>
+          <a:ln/>
+        </p:spPr>
+        <p:txBody>
+          <a:bodyPr/>
+          <a:p/>
+        </p:txBody>
+      </p:sp>
+      <p:sp>
+        <p:nvSpPr>
+          <p:cNvPr id="23" name="TextBox 22"/>
+          <p:cNvSpPr txBox="1"/>
+          <p:nvPr/>
+        </p:nvSpPr>
+        <p:spPr>
+          <a:xfrm>
+            <a:off x="640080" y="4069080"/>
+            <a:ext cx="7863840" cy="685800"/>
+          </a:xfrm>
+          <a:prstGeom prst="rect">
+            <a:avLst/>
+          </a:prstGeom>
+          <a:noFill/>
+        </p:spPr>
+        <p:txBody>
+          <a:bodyPr wrap="square" lIns="0" rIns="0" tIns="0" bIns="0" anchor="ctr">
+            <a:spAutoFit/>
+          </a:bodyPr>
+          <a:lstStyle/>
+          <a:p>
+            <a:r>
+              <a:rPr sz="1250" b="1">
+                <a:solidFill>
+                  <a:srgbClr val="5A1030"/>
+                </a:solidFill>
+                <a:latin typeface="Arial"/>
+              </a:rPr>
+              <a:t>RPI = 0.40 x QS Citations/Faculty + 0.35 x THE Research + 0.25 x THE Citations</a:t>
+            </a:r>
+          </a:p>
+        </p:txBody>
+      </p:sp>
+    </p:spTree>
+  </p:cSld>
+  <p:clrMapOvr>
+    <a:masterClrMapping/>
+  </p:clrMapOvr>
+  <p:transition spd="med">
+    <p:push dir="l"/>
+  </p:transition>
+</p:sld>
+</file>
+
+<file path=ppt/slides/slide19.xml><?xml version="1.0" encoding="utf-8"?>
+<p:sld xmlns:a="http://schemas.openxmlformats.org/drawingml/2006/main" xmlns:p="http://schemas.openxmlformats.org/presentationml/2006/main" xmlns:r="http://schemas.openxmlformats.org/officeDocument/2006/relationships">
+  <p:cSld>
+    <p:spTree>
+      <p:nvGrpSpPr>
+        <p:cNvPr id="1" name=""/>
+        <p:cNvGrpSpPr/>
+        <p:nvPr/>
+      </p:nvGrpSpPr>
+      <p:grpSpPr/>
+      <p:sp>
+        <p:nvSpPr>
+          <p:cNvPr id="2" name="Shape 0"/>
+          <p:cNvSpPr/>
+          <p:nvPr/>
+        </p:nvSpPr>
+        <p:spPr>
+          <a:xfrm>
+            <a:off x="7863840" y="-822960"/>
+            <a:ext cx="2011680" cy="2011680"/>
+          </a:xfrm>
+          <a:prstGeom prst="ellipse">
+            <a:avLst/>
+          </a:prstGeom>
+          <a:solidFill>
+            <a:srgbClr val="FFB030">
+              <a:alpha val="30000"/>
+            </a:srgbClr>
+          </a:solidFill>
+          <a:ln/>
+        </p:spPr>
+        <p:txBody>
+          <a:bodyPr/>
+          <a:p/>
+        </p:txBody>
+      </p:sp>
+      <p:sp>
+        <p:nvSpPr>
+          <p:cNvPr id="3" name="Shape 1"/>
+          <p:cNvSpPr/>
+          <p:nvPr/>
+        </p:nvSpPr>
+        <p:spPr>
+          <a:xfrm>
+            <a:off x="274320" y="274320"/>
+            <a:ext cx="164592" cy="164592"/>
+          </a:xfrm>
+          <a:prstGeom prst="ellipse">
+            <a:avLst/>
+          </a:prstGeom>
+          <a:solidFill>
+            <a:srgbClr val="E8442F"/>
+          </a:solidFill>
+          <a:ln/>
+        </p:spPr>
+        <p:txBody>
+          <a:bodyPr/>
+          <a:p/>
+        </p:txBody>
+      </p:sp>
+      <p:sp>
+        <p:nvSpPr>
+          <p:cNvPr id="4" name="Text 2"/>
+          <p:cNvSpPr txBox="1"/>
+          <p:nvPr/>
+        </p:nvSpPr>
+        <p:spPr>
+          <a:xfrm>
+            <a:off x="502920" y="201168"/>
+            <a:ext cx="1828800" cy="320040"/>
+          </a:xfrm>
+          <a:prstGeom prst="rect">
+            <a:avLst/>
+          </a:prstGeom>
+          <a:noFill/>
+          <a:ln/>
+        </p:spPr>
+        <p:txBody>
+          <a:bodyPr wrap="square" lIns="0" tIns="0" rIns="0" bIns="0" rtlCol="0" anchor="ctr"/>
+          <a:lstStyle/>
+          <a:p>
+            <a:pPr marL="0" indent="0">
+              <a:buNone/>
+            </a:pPr>
+            <a:r>
+              <a:rPr lang="en-US" sz="1100" b="1" dirty="0">
+                <a:solidFill>
+                  <a:srgbClr val="E8442F"/>
+                </a:solidFill>
+                <a:latin typeface="Arial" pitchFamily="34" charset="0"/>
+                <a:ea typeface="Arial" pitchFamily="34" charset="-122"/>
+                <a:cs typeface="Arial" pitchFamily="34" charset="-120"/>
+              </a:rPr>
+              <a:t>EduVision</a:t>
+            </a:r>
+            <a:endParaRPr lang="en-US" sz="1100" dirty="0"/>
+          </a:p>
+        </p:txBody>
+      </p:sp>
+      <p:sp>
+        <p:nvSpPr>
+          <p:cNvPr id="5" name="Text 3"/>
+          <p:cNvSpPr txBox="1"/>
+          <p:nvPr/>
+        </p:nvSpPr>
+        <p:spPr>
+          <a:xfrm>
+            <a:off x="8138160" y="4709160"/>
+            <a:ext cx="640080" cy="274320"/>
+          </a:xfrm>
+          <a:prstGeom prst="rect">
+            <a:avLst/>
+          </a:prstGeom>
+          <a:noFill/>
+          <a:ln/>
+        </p:spPr>
+        <p:txBody>
+          <a:bodyPr wrap="square" lIns="0" tIns="0" rIns="0" bIns="0" rtlCol="0" anchor="ctr"/>
+          <a:lstStyle/>
+          <a:p>
+            <a:pPr marL="0" indent="0" algn="r">
+              <a:buNone/>
+            </a:pPr>
+            <a:r>
+              <a:rPr lang="en-US" sz="1000" dirty="0">
+                <a:solidFill>
+                  <a:srgbClr val="F47B20"/>
+                </a:solidFill>
+                <a:latin typeface="Arial" pitchFamily="34" charset="0"/>
+                <a:ea typeface="Arial" pitchFamily="34" charset="-122"/>
+                <a:cs typeface="Arial" pitchFamily="34" charset="-120"/>
+              </a:rPr>
+              <a:t>14</a:t>
+            </a:r>
+            <a:endParaRPr lang="en-US" sz="1000" dirty="0"/>
+          </a:p>
+        </p:txBody>
+      </p:sp>
+      <p:sp>
+        <p:nvSpPr>
+          <p:cNvPr id="6" name="Text 4"/>
+          <p:cNvSpPr txBox="1"/>
+          <p:nvPr/>
+        </p:nvSpPr>
+        <p:spPr>
+          <a:xfrm>
+            <a:off x="457200" y="640080"/>
+            <a:ext cx="8229600" cy="640080"/>
+          </a:xfrm>
+          <a:prstGeom prst="rect">
+            <a:avLst/>
+          </a:prstGeom>
+          <a:noFill/>
+          <a:ln/>
+        </p:spPr>
+        <p:txBody>
+          <a:bodyPr wrap="square" lIns="0" tIns="0" rIns="0" bIns="0" rtlCol="0" anchor="ctr"/>
+          <a:lstStyle/>
+          <a:p>
+            <a:pPr marL="0" indent="0">
+              <a:buNone/>
+            </a:pPr>
+            <a:r>
+              <a:rPr lang="en-US" sz="2600" b="1" dirty="0">
+                <a:solidFill>
+                  <a:srgbClr val="E8442F"/>
+                </a:solidFill>
+                <a:latin typeface="Arial" pitchFamily="34" charset="0"/>
+                <a:ea typeface="Arial" pitchFamily="34" charset="-122"/>
+                <a:cs typeface="Arial" pitchFamily="34" charset="-120"/>
+              </a:rPr>
+              <a:t>Results</a:t>
+            </a:r>
+            <a:endParaRPr lang="en-US" sz="2600" dirty="0"/>
+          </a:p>
+        </p:txBody>
+      </p:sp>
+      <p:sp>
+        <p:nvSpPr>
+          <p:cNvPr id="7" name="Shape 5"/>
+          <p:cNvSpPr/>
+          <p:nvPr/>
+        </p:nvSpPr>
+        <p:spPr>
+          <a:xfrm>
+            <a:off x="457200" y="1645920"/>
+            <a:ext cx="2590800" cy="1554480"/>
+          </a:xfrm>
+          <a:prstGeom prst="roundRect">
+            <a:avLst>
+              <a:gd name="adj" fmla="val 7059"/>
+            </a:avLst>
+          </a:prstGeom>
+          <a:solidFill>
+            <a:srgbClr val="FFF1E8"/>
+          </a:solidFill>
+          <a:ln w="12700">
+            <a:solidFill>
+              <a:srgbClr val="F47B20"/>
+            </a:solidFill>
+            <a:prstDash val="solid"/>
+          </a:ln>
+        </p:spPr>
+        <p:txBody>
+          <a:bodyPr/>
+          <a:p/>
+        </p:txBody>
+      </p:sp>
+      <p:sp>
+        <p:nvSpPr>
+          <p:cNvPr id="8" name="Text 6"/>
+          <p:cNvSpPr txBox="1"/>
+          <p:nvPr/>
+        </p:nvSpPr>
+        <p:spPr>
+          <a:xfrm>
+            <a:off x="457200" y="1828800"/>
+            <a:ext cx="2590800" cy="731520"/>
+          </a:xfrm>
+          <a:prstGeom prst="rect">
+            <a:avLst/>
+          </a:prstGeom>
+          <a:noFill/>
+          <a:ln/>
+        </p:spPr>
+        <p:txBody>
+          <a:bodyPr wrap="square" lIns="0" tIns="0" rIns="0" bIns="0" rtlCol="0" anchor="ctr"/>
+          <a:lstStyle/>
+          <a:p>
+            <a:pPr marL="0" indent="0" algn="ctr">
+              <a:buNone/>
+            </a:pPr>
+            <a:r>
+              <a:rPr lang="en-US" sz="3000" b="1" dirty="0">
+                <a:solidFill>
+                  <a:srgbClr val="E8442F"/>
+                </a:solidFill>
+                <a:latin typeface="Arial" pitchFamily="34" charset="0"/>
+                <a:ea typeface="Arial" pitchFamily="34" charset="-122"/>
+                <a:cs typeface="Arial" pitchFamily="34" charset="-120"/>
+              </a:rPr>
+              <a:t>41.84</a:t>
+            </a:r>
+            <a:endParaRPr lang="en-US" sz="3000" dirty="0"/>
+          </a:p>
+        </p:txBody>
+      </p:sp>
+      <p:sp>
+        <p:nvSpPr>
+          <p:cNvPr id="9" name="Text 7"/>
+          <p:cNvSpPr txBox="1"/>
+          <p:nvPr/>
+        </p:nvSpPr>
+        <p:spPr>
+          <a:xfrm>
+            <a:off x="548640" y="2560320"/>
+            <a:ext cx="2407920" cy="548640"/>
+          </a:xfrm>
+          <a:prstGeom prst="rect">
+            <a:avLst/>
+          </a:prstGeom>
+          <a:noFill/>
+          <a:ln/>
+        </p:spPr>
+        <p:txBody>
+          <a:bodyPr wrap="square" lIns="0" tIns="0" rIns="0" bIns="0" rtlCol="0" anchor="t"/>
+          <a:lstStyle/>
+          <a:p>
+            <a:pPr marL="0" indent="0" algn="ctr">
+              <a:buNone/>
+            </a:pPr>
+            <a:r>
+              <a:rPr lang="en-US" sz="1150" dirty="0">
+                <a:solidFill>
+                  <a:srgbClr val="3A2A2A"/>
+                </a:solidFill>
+                <a:latin typeface="Arial" pitchFamily="34" charset="0"/>
+                <a:ea typeface="Arial" pitchFamily="34" charset="-122"/>
+                <a:cs typeface="Arial" pitchFamily="34" charset="-120"/>
+              </a:rPr>
+              <a:t>avg Global Ranking Score</a:t>
+            </a:r>
+            <a:endParaRPr lang="en-US" sz="1150" dirty="0"/>
+          </a:p>
+        </p:txBody>
+      </p:sp>
+      <p:sp>
+        <p:nvSpPr>
+          <p:cNvPr id="10" name="Shape 8"/>
+          <p:cNvSpPr/>
+          <p:nvPr/>
+        </p:nvSpPr>
+        <p:spPr>
+          <a:xfrm>
+            <a:off x="3276600" y="1645920"/>
+            <a:ext cx="2590800" cy="1554480"/>
+          </a:xfrm>
+          <a:prstGeom prst="roundRect">
+            <a:avLst>
+              <a:gd name="adj" fmla="val 7059"/>
+            </a:avLst>
+          </a:prstGeom>
+          <a:solidFill>
+            <a:srgbClr val="FFF1E8"/>
+          </a:solidFill>
+          <a:ln w="12700">
+            <a:solidFill>
+              <a:srgbClr val="F47B20"/>
+            </a:solidFill>
+            <a:prstDash val="solid"/>
+          </a:ln>
+        </p:spPr>
+        <p:txBody>
+          <a:bodyPr/>
+          <a:p/>
+        </p:txBody>
+      </p:sp>
+      <p:sp>
+        <p:nvSpPr>
+          <p:cNvPr id="11" name="Text 9"/>
+          <p:cNvSpPr txBox="1"/>
+          <p:nvPr/>
+        </p:nvSpPr>
+        <p:spPr>
+          <a:xfrm>
+            <a:off x="3276600" y="1828800"/>
+            <a:ext cx="2590800" cy="731520"/>
+          </a:xfrm>
+          <a:prstGeom prst="rect">
+            <a:avLst/>
+          </a:prstGeom>
+          <a:noFill/>
+          <a:ln/>
+        </p:spPr>
+        <p:txBody>
+          <a:bodyPr wrap="square" lIns="0" tIns="0" rIns="0" bIns="0" rtlCol="0" anchor="ctr"/>
+          <a:lstStyle/>
+          <a:p>
+            <a:pPr marL="0" indent="0" algn="ctr">
+              <a:buNone/>
+            </a:pPr>
+            <a:r>
+              <a:rPr lang="en-US" sz="3000" b="1" dirty="0">
+                <a:solidFill>
+                  <a:srgbClr val="E8442F"/>
+                </a:solidFill>
+                <a:latin typeface="Arial" pitchFamily="34" charset="0"/>
+                <a:ea typeface="Arial" pitchFamily="34" charset="-122"/>
+                <a:cs typeface="Arial" pitchFamily="34" charset="-120"/>
+              </a:rPr>
+              <a:t>23.50</a:t>
+            </a:r>
+            <a:endParaRPr lang="en-US" sz="3000" dirty="0"/>
+          </a:p>
+        </p:txBody>
+      </p:sp>
+      <p:sp>
+        <p:nvSpPr>
+          <p:cNvPr id="12" name="Text 10"/>
+          <p:cNvSpPr txBox="1"/>
+          <p:nvPr/>
+        </p:nvSpPr>
+        <p:spPr>
+          <a:xfrm>
+            <a:off x="3368040" y="2560320"/>
+            <a:ext cx="2407920" cy="548640"/>
+          </a:xfrm>
+          <a:prstGeom prst="rect">
+            <a:avLst/>
+          </a:prstGeom>
+          <a:noFill/>
+          <a:ln/>
+        </p:spPr>
+        <p:txBody>
+          <a:bodyPr wrap="square" lIns="0" tIns="0" rIns="0" bIns="0" rtlCol="0" anchor="t"/>
+          <a:lstStyle/>
+          <a:p>
+            <a:pPr marL="0" indent="0" algn="ctr">
+              <a:buNone/>
+            </a:pPr>
+            <a:r>
+              <a:rPr lang="en-US" sz="1150" dirty="0">
+                <a:solidFill>
+                  <a:srgbClr val="3A2A2A"/>
+                </a:solidFill>
+                <a:latin typeface="Arial" pitchFamily="34" charset="0"/>
+                <a:ea typeface="Arial" pitchFamily="34" charset="-122"/>
+                <a:cs typeface="Arial" pitchFamily="34" charset="-120"/>
+              </a:rPr>
+              <a:t>avg Research Impact Score</a:t>
+            </a:r>
+            <a:endParaRPr lang="en-US" sz="1150" dirty="0"/>
+          </a:p>
+        </p:txBody>
+      </p:sp>
+      <p:sp>
+        <p:nvSpPr>
+          <p:cNvPr id="13" name="Shape 11"/>
+          <p:cNvSpPr/>
+          <p:nvPr/>
+        </p:nvSpPr>
+        <p:spPr>
+          <a:xfrm>
+            <a:off x="6096000" y="1645920"/>
+            <a:ext cx="2590800" cy="1554480"/>
+          </a:xfrm>
+          <a:prstGeom prst="roundRect">
+            <a:avLst>
+              <a:gd name="adj" fmla="val 7059"/>
+            </a:avLst>
+          </a:prstGeom>
+          <a:solidFill>
+            <a:srgbClr val="FFF1E8"/>
+          </a:solidFill>
+          <a:ln w="12700">
+            <a:solidFill>
+              <a:srgbClr val="F47B20"/>
+            </a:solidFill>
+            <a:prstDash val="solid"/>
+          </a:ln>
+        </p:spPr>
+        <p:txBody>
+          <a:bodyPr/>
+          <a:p/>
+        </p:txBody>
+      </p:sp>
+      <p:sp>
+        <p:nvSpPr>
+          <p:cNvPr id="14" name="Text 12"/>
+          <p:cNvSpPr txBox="1"/>
+          <p:nvPr/>
+        </p:nvSpPr>
+        <p:spPr>
+          <a:xfrm>
+            <a:off x="6096000" y="1828800"/>
+            <a:ext cx="2590800" cy="731520"/>
+          </a:xfrm>
+          <a:prstGeom prst="rect">
+            <a:avLst/>
+          </a:prstGeom>
+          <a:noFill/>
+          <a:ln/>
+        </p:spPr>
+        <p:txBody>
+          <a:bodyPr wrap="square" lIns="0" tIns="0" rIns="0" bIns="0" rtlCol="0" anchor="ctr"/>
+          <a:lstStyle/>
+          <a:p>
+            <a:pPr marL="0" indent="0" algn="ctr">
+              <a:buNone/>
+            </a:pPr>
+            <a:r>
+              <a:rPr lang="en-US" sz="3000" b="1" dirty="0">
+                <a:solidFill>
+                  <a:srgbClr val="E8442F"/>
+                </a:solidFill>
+                <a:latin typeface="Arial" pitchFamily="34" charset="0"/>
+                <a:ea typeface="Arial" pitchFamily="34" charset="-122"/>
+                <a:cs typeface="Arial" pitchFamily="34" charset="-120"/>
+              </a:rPr>
+              <a:t>20.29</a:t>
+            </a:r>
+            <a:endParaRPr lang="en-US" sz="3000" dirty="0"/>
+          </a:p>
+        </p:txBody>
+      </p:sp>
+      <p:sp>
+        <p:nvSpPr>
+          <p:cNvPr id="15" name="Text 13"/>
+          <p:cNvSpPr txBox="1"/>
+          <p:nvPr/>
+        </p:nvSpPr>
+        <p:spPr>
+          <a:xfrm>
+            <a:off x="6187440" y="2560320"/>
+            <a:ext cx="2407920" cy="548640"/>
+          </a:xfrm>
+          <a:prstGeom prst="rect">
+            <a:avLst/>
+          </a:prstGeom>
+          <a:noFill/>
+          <a:ln/>
+        </p:spPr>
+        <p:txBody>
+          <a:bodyPr wrap="square" lIns="0" tIns="0" rIns="0" bIns="0" rtlCol="0" anchor="t"/>
+          <a:lstStyle/>
+          <a:p>
+            <a:pPr marL="0" indent="0" algn="ctr">
+              <a:buNone/>
+            </a:pPr>
+            <a:r>
+              <a:rPr lang="en-US" sz="1150" dirty="0">
+                <a:solidFill>
+                  <a:srgbClr val="3A2A2A"/>
+                </a:solidFill>
+                <a:latin typeface="Arial" pitchFamily="34" charset="0"/>
+                <a:ea typeface="Arial" pitchFamily="34" charset="-122"/>
+                <a:cs typeface="Arial" pitchFamily="34" charset="-120"/>
+              </a:rPr>
+              <a:t>avg Academic Reputation</a:t>
+            </a:r>
+            <a:endParaRPr lang="en-US" sz="1150" dirty="0"/>
+          </a:p>
+        </p:txBody>
+      </p:sp>
+      <p:sp>
+        <p:nvSpPr>
+          <p:cNvPr id="21" name="Shape 19"/>
+          <p:cNvSpPr/>
+          <p:nvPr/>
+        </p:nvSpPr>
+        <p:spPr>
+          <a:xfrm>
+            <a:off x="457200" y="3566160"/>
+            <a:ext cx="8229600" cy="685800"/>
+          </a:xfrm>
+          <a:prstGeom prst="roundRect">
+            <a:avLst>
+              <a:gd name="adj" fmla="val 13333"/>
+            </a:avLst>
+          </a:prstGeom>
+          <a:solidFill>
+            <a:srgbClr val="FFF1E8"/>
+          </a:solidFill>
+          <a:ln/>
+        </p:spPr>
+        <p:txBody>
+          <a:bodyPr/>
+          <a:p/>
+        </p:txBody>
+      </p:sp>
+      <p:sp>
+        <p:nvSpPr>
+          <p:cNvPr id="22" name="TextBox 21"/>
+          <p:cNvSpPr txBox="1"/>
+          <p:nvPr/>
+        </p:nvSpPr>
+        <p:spPr>
+          <a:xfrm>
+            <a:off x="640080" y="3566160"/>
+            <a:ext cx="7863840" cy="685800"/>
+          </a:xfrm>
+          <a:prstGeom prst="rect">
+            <a:avLst/>
+          </a:prstGeom>
+          <a:noFill/>
+        </p:spPr>
+        <p:txBody>
+          <a:bodyPr wrap="square" lIns="0" rIns="0" tIns="0" bIns="0" anchor="ctr">
+            <a:spAutoFit/>
+          </a:bodyPr>
+          <a:lstStyle/>
+          <a:p>
+            <a:r>
+              <a:rPr sz="1250" b="1">
+                <a:solidFill>
+                  <a:srgbClr val="5A1030"/>
+                </a:solidFill>
+                <a:latin typeface="Arial"/>
+              </a:rPr>
+              <a:t>Python-generated KPI averages matched the Tableau dashboard values.</a:t>
+            </a:r>
+          </a:p>
+        </p:txBody>
+      </p:sp>
+    </p:spTree>
+  </p:cSld>
+  <p:clrMapOvr>
+    <a:masterClrMapping/>
+  </p:clrMapOvr>
+  <p:transition spd="med">
+    <p:wipe dir="r"/>
   </p:transition>
 </p:sld>
 </file>
@@ -6409,6 +7972,10 @@
           </a:solidFill>
           <a:ln/>
         </p:spPr>
+        <p:txBody>
+          <a:bodyPr/>
+          <a:p/>
+        </p:txBody>
       </p:sp>
       <p:sp>
         <p:nvSpPr>
@@ -6429,6 +7996,10 @@
           </a:solidFill>
           <a:ln/>
         </p:spPr>
+        <p:txBody>
+          <a:bodyPr/>
+          <a:p/>
+        </p:txBody>
       </p:sp>
       <p:sp>
         <p:nvSpPr>
@@ -6660,6 +8231,879 @@
   </p:clrMapOvr>
   <p:transition spd="med">
     <p:wipe dir="r"/>
+  </p:transition>
+</p:sld>
+</file>
+
+<file path=ppt/slides/slide20.xml><?xml version="1.0" encoding="utf-8"?>
+<p:sld xmlns:a="http://schemas.openxmlformats.org/drawingml/2006/main" xmlns:p="http://schemas.openxmlformats.org/presentationml/2006/main" xmlns:r="http://schemas.openxmlformats.org/officeDocument/2006/relationships">
+  <p:cSld>
+    <p:spTree>
+      <p:nvGrpSpPr>
+        <p:cNvPr id="1" name=""/>
+        <p:cNvGrpSpPr/>
+        <p:nvPr/>
+      </p:nvGrpSpPr>
+      <p:grpSpPr/>
+      <p:sp>
+        <p:nvSpPr>
+          <p:cNvPr id="2" name="Shape 0"/>
+          <p:cNvSpPr/>
+          <p:nvPr/>
+        </p:nvSpPr>
+        <p:spPr>
+          <a:xfrm>
+            <a:off x="7863840" y="-822960"/>
+            <a:ext cx="2011680" cy="2011680"/>
+          </a:xfrm>
+          <a:prstGeom prst="ellipse">
+            <a:avLst/>
+          </a:prstGeom>
+          <a:solidFill>
+            <a:srgbClr val="FFB030">
+              <a:alpha val="30000"/>
+            </a:srgbClr>
+          </a:solidFill>
+          <a:ln/>
+        </p:spPr>
+        <p:txBody>
+          <a:bodyPr/>
+          <a:p/>
+        </p:txBody>
+      </p:sp>
+      <p:sp>
+        <p:nvSpPr>
+          <p:cNvPr id="3" name="Shape 1"/>
+          <p:cNvSpPr/>
+          <p:nvPr/>
+        </p:nvSpPr>
+        <p:spPr>
+          <a:xfrm>
+            <a:off x="274320" y="274320"/>
+            <a:ext cx="164592" cy="164592"/>
+          </a:xfrm>
+          <a:prstGeom prst="ellipse">
+            <a:avLst/>
+          </a:prstGeom>
+          <a:solidFill>
+            <a:srgbClr val="E8442F"/>
+          </a:solidFill>
+          <a:ln/>
+        </p:spPr>
+        <p:txBody>
+          <a:bodyPr/>
+          <a:p/>
+        </p:txBody>
+      </p:sp>
+      <p:sp>
+        <p:nvSpPr>
+          <p:cNvPr id="4" name="Text 2"/>
+          <p:cNvSpPr txBox="1"/>
+          <p:nvPr/>
+        </p:nvSpPr>
+        <p:spPr>
+          <a:xfrm>
+            <a:off x="502920" y="201168"/>
+            <a:ext cx="1828800" cy="320040"/>
+          </a:xfrm>
+          <a:prstGeom prst="rect">
+            <a:avLst/>
+          </a:prstGeom>
+          <a:noFill/>
+          <a:ln/>
+        </p:spPr>
+        <p:txBody>
+          <a:bodyPr wrap="square" lIns="0" tIns="0" rIns="0" bIns="0" rtlCol="0" anchor="ctr"/>
+          <a:lstStyle/>
+          <a:p>
+            <a:pPr marL="0" indent="0">
+              <a:buNone/>
+            </a:pPr>
+            <a:r>
+              <a:rPr lang="en-US" sz="1100" b="1" dirty="0">
+                <a:solidFill>
+                  <a:srgbClr val="E8442F"/>
+                </a:solidFill>
+                <a:latin typeface="Arial" pitchFamily="34" charset="0"/>
+                <a:ea typeface="Arial" pitchFamily="34" charset="-122"/>
+                <a:cs typeface="Arial" pitchFamily="34" charset="-120"/>
+              </a:rPr>
+              <a:t>EduVision</a:t>
+            </a:r>
+            <a:endParaRPr lang="en-US" sz="1100" dirty="0"/>
+          </a:p>
+        </p:txBody>
+      </p:sp>
+      <p:sp>
+        <p:nvSpPr>
+          <p:cNvPr id="5" name="Text 3"/>
+          <p:cNvSpPr txBox="1"/>
+          <p:nvPr/>
+        </p:nvSpPr>
+        <p:spPr>
+          <a:xfrm>
+            <a:off x="8138160" y="4709160"/>
+            <a:ext cx="640080" cy="274320"/>
+          </a:xfrm>
+          <a:prstGeom prst="rect">
+            <a:avLst/>
+          </a:prstGeom>
+          <a:noFill/>
+          <a:ln/>
+        </p:spPr>
+        <p:txBody>
+          <a:bodyPr wrap="square" lIns="0" tIns="0" rIns="0" bIns="0" rtlCol="0" anchor="ctr"/>
+          <a:lstStyle/>
+          <a:p>
+            <a:pPr marL="0" indent="0" algn="r">
+              <a:buNone/>
+            </a:pPr>
+            <a:r>
+              <a:rPr lang="en-US" sz="1000" dirty="0">
+                <a:solidFill>
+                  <a:srgbClr val="F47B20"/>
+                </a:solidFill>
+                <a:latin typeface="Arial" pitchFamily="34" charset="0"/>
+                <a:ea typeface="Arial" pitchFamily="34" charset="-122"/>
+                <a:cs typeface="Arial" pitchFamily="34" charset="-120"/>
+              </a:rPr>
+              <a:t>15</a:t>
+            </a:r>
+            <a:endParaRPr lang="en-US" sz="1000" dirty="0"/>
+          </a:p>
+        </p:txBody>
+      </p:sp>
+      <p:sp>
+        <p:nvSpPr>
+          <p:cNvPr id="6" name="Text 4"/>
+          <p:cNvSpPr txBox="1"/>
+          <p:nvPr/>
+        </p:nvSpPr>
+        <p:spPr>
+          <a:xfrm>
+            <a:off x="457200" y="640080"/>
+            <a:ext cx="8229600" cy="640080"/>
+          </a:xfrm>
+          <a:prstGeom prst="rect">
+            <a:avLst/>
+          </a:prstGeom>
+          <a:noFill/>
+          <a:ln/>
+        </p:spPr>
+        <p:txBody>
+          <a:bodyPr wrap="square" lIns="0" tIns="0" rIns="0" bIns="0" rtlCol="0" anchor="ctr"/>
+          <a:lstStyle/>
+          <a:p>
+            <a:pPr marL="0" indent="0">
+              <a:buNone/>
+            </a:pPr>
+            <a:r>
+              <a:rPr lang="en-US" sz="2600" b="1" dirty="0">
+                <a:solidFill>
+                  <a:srgbClr val="E8442F"/>
+                </a:solidFill>
+                <a:latin typeface="Arial" pitchFamily="34" charset="0"/>
+                <a:ea typeface="Arial" pitchFamily="34" charset="-122"/>
+                <a:cs typeface="Arial" pitchFamily="34" charset="-120"/>
+              </a:rPr>
+              <a:t>Key Insights</a:t>
+            </a:r>
+            <a:endParaRPr lang="en-US" sz="2600" dirty="0"/>
+          </a:p>
+        </p:txBody>
+      </p:sp>
+      <p:sp>
+        <p:nvSpPr>
+          <p:cNvPr id="7" name="Text 5"/>
+          <p:cNvSpPr txBox="1"/>
+          <p:nvPr/>
+        </p:nvSpPr>
+        <p:spPr>
+          <a:xfrm>
+            <a:off x="457200" y="1554480"/>
+            <a:ext cx="8229600" cy="2926080"/>
+          </a:xfrm>
+          <a:prstGeom prst="rect">
+            <a:avLst/>
+          </a:prstGeom>
+          <a:noFill/>
+          <a:ln/>
+        </p:spPr>
+        <p:txBody>
+          <a:bodyPr wrap="square" lIns="0" tIns="0" rIns="0" bIns="0" rtlCol="0" anchor="t"/>
+          <a:lstStyle/>
+          <a:p>
+            <a:pPr marL="342900" indent="-342900">
+              <a:spcAft>
+                <a:spcPts val="700"/>
+              </a:spcAft>
+              <a:buSzPct val="100000"/>
+              <a:buChar char="●"/>
+            </a:pPr>
+            <a:r>
+              <a:rPr lang="en-US" sz="1500" dirty="0">
+                <a:solidFill>
+                  <a:srgbClr val="3A2A2A"/>
+                </a:solidFill>
+                <a:latin typeface="Arial" pitchFamily="34" charset="0"/>
+                <a:ea typeface="Arial" pitchFamily="34" charset="-122"/>
+                <a:cs typeface="Arial" pitchFamily="34" charset="-120"/>
+              </a:rPr>
+              <a:t>MIT leads the Global Ranking Score at 100.0, followed by Imperial College London (98.5) and Oxford (96.9)</a:t>
+            </a:r>
+            <a:endParaRPr lang="en-US" sz="1500" dirty="0"/>
+          </a:p>
+          <a:p>
+            <a:pPr marL="342900" indent="-342900">
+              <a:spcAft>
+                <a:spcPts val="700"/>
+              </a:spcAft>
+              <a:buSzPct val="100000"/>
+              <a:buChar char="●"/>
+            </a:pPr>
+            <a:r>
+              <a:rPr lang="en-US" sz="1500" dirty="0">
+                <a:solidFill>
+                  <a:srgbClr val="3A2A2A"/>
+                </a:solidFill>
+                <a:latin typeface="Arial" pitchFamily="34" charset="0"/>
+                <a:ea typeface="Arial" pitchFamily="34" charset="-122"/>
+                <a:cs typeface="Arial" pitchFamily="34" charset="-120"/>
+              </a:rPr>
+              <a:t>Top 10 also includes Harvard, Cambridge, Stanford, ETH Zurich, NUS, UCL and Caltech</a:t>
+            </a:r>
+            <a:endParaRPr lang="en-US" sz="1500" dirty="0"/>
+          </a:p>
+          <a:p>
+            <a:pPr marL="342900" indent="-342900">
+              <a:spcAft>
+                <a:spcPts val="700"/>
+              </a:spcAft>
+              <a:buSzPct val="100000"/>
+              <a:buChar char="●"/>
+            </a:pPr>
+            <a:r>
+              <a:rPr lang="en-US" sz="1500" dirty="0">
+                <a:solidFill>
+                  <a:srgbClr val="3A2A2A"/>
+                </a:solidFill>
+                <a:latin typeface="Arial" pitchFamily="34" charset="0"/>
+                <a:ea typeface="Arial" pitchFamily="34" charset="-122"/>
+                <a:cs typeface="Arial" pitchFamily="34" charset="-120"/>
+              </a:rPr>
+              <a:t>Average scores sit well below the leaders: the performance gap is wide</a:t>
+            </a:r>
+            <a:endParaRPr lang="en-US" sz="1500" dirty="0"/>
+          </a:p>
+          <a:p>
+            <a:pPr marL="342900" indent="-342900">
+              <a:spcAft>
+                <a:spcPts val="700"/>
+              </a:spcAft>
+              <a:buSzPct val="100000"/>
+              <a:buChar char="●"/>
+            </a:pPr>
+            <a:r>
+              <a:rPr lang="en-US" sz="1500" dirty="0">
+                <a:solidFill>
+                  <a:srgbClr val="3A2A2A"/>
+                </a:solidFill>
+                <a:latin typeface="Arial" pitchFamily="34" charset="0"/>
+                <a:ea typeface="Arial" pitchFamily="34" charset="-122"/>
+                <a:cs typeface="Arial" pitchFamily="34" charset="-120"/>
+              </a:rPr>
+              <a:t>Country linkage to World Bank data adds education context to rankings</a:t>
+            </a:r>
+            <a:endParaRPr lang="en-US" sz="1500" dirty="0"/>
+          </a:p>
+        </p:txBody>
+      </p:sp>
+    </p:spTree>
+  </p:cSld>
+  <p:clrMapOvr>
+    <a:masterClrMapping/>
+  </p:clrMapOvr>
+  <p:transition spd="med">
+    <p:fade/>
+  </p:transition>
+</p:sld>
+</file>
+
+<file path=ppt/slides/slide21.xml><?xml version="1.0" encoding="utf-8"?>
+<p:sld xmlns:a="http://schemas.openxmlformats.org/drawingml/2006/main" xmlns:p="http://schemas.openxmlformats.org/presentationml/2006/main" xmlns:r="http://schemas.openxmlformats.org/officeDocument/2006/relationships">
+  <p:cSld>
+    <p:spTree>
+      <p:nvGrpSpPr>
+        <p:cNvPr id="1" name=""/>
+        <p:cNvGrpSpPr/>
+        <p:nvPr/>
+      </p:nvGrpSpPr>
+      <p:grpSpPr/>
+      <p:sp>
+        <p:nvSpPr>
+          <p:cNvPr id="2" name="Shape 0"/>
+          <p:cNvSpPr/>
+          <p:nvPr/>
+        </p:nvSpPr>
+        <p:spPr>
+          <a:xfrm>
+            <a:off x="7863840" y="-822960"/>
+            <a:ext cx="2011680" cy="2011680"/>
+          </a:xfrm>
+          <a:prstGeom prst="ellipse">
+            <a:avLst/>
+          </a:prstGeom>
+          <a:solidFill>
+            <a:srgbClr val="FFB030">
+              <a:alpha val="30000"/>
+            </a:srgbClr>
+          </a:solidFill>
+          <a:ln/>
+        </p:spPr>
+        <p:txBody>
+          <a:bodyPr/>
+          <a:p/>
+        </p:txBody>
+      </p:sp>
+      <p:sp>
+        <p:nvSpPr>
+          <p:cNvPr id="3" name="Shape 1"/>
+          <p:cNvSpPr/>
+          <p:nvPr/>
+        </p:nvSpPr>
+        <p:spPr>
+          <a:xfrm>
+            <a:off x="274320" y="274320"/>
+            <a:ext cx="164592" cy="164592"/>
+          </a:xfrm>
+          <a:prstGeom prst="ellipse">
+            <a:avLst/>
+          </a:prstGeom>
+          <a:solidFill>
+            <a:srgbClr val="E8442F"/>
+          </a:solidFill>
+          <a:ln/>
+        </p:spPr>
+        <p:txBody>
+          <a:bodyPr/>
+          <a:p/>
+        </p:txBody>
+      </p:sp>
+      <p:sp>
+        <p:nvSpPr>
+          <p:cNvPr id="4" name="Text 2"/>
+          <p:cNvSpPr txBox="1"/>
+          <p:nvPr/>
+        </p:nvSpPr>
+        <p:spPr>
+          <a:xfrm>
+            <a:off x="502920" y="201168"/>
+            <a:ext cx="1828800" cy="320040"/>
+          </a:xfrm>
+          <a:prstGeom prst="rect">
+            <a:avLst/>
+          </a:prstGeom>
+          <a:noFill/>
+          <a:ln/>
+        </p:spPr>
+        <p:txBody>
+          <a:bodyPr wrap="square" lIns="0" tIns="0" rIns="0" bIns="0" rtlCol="0" anchor="ctr"/>
+          <a:lstStyle/>
+          <a:p>
+            <a:pPr marL="0" indent="0">
+              <a:buNone/>
+            </a:pPr>
+            <a:r>
+              <a:rPr lang="en-US" sz="1100" b="1" dirty="0">
+                <a:solidFill>
+                  <a:srgbClr val="E8442F"/>
+                </a:solidFill>
+                <a:latin typeface="Arial" pitchFamily="34" charset="0"/>
+                <a:ea typeface="Arial" pitchFamily="34" charset="-122"/>
+                <a:cs typeface="Arial" pitchFamily="34" charset="-120"/>
+              </a:rPr>
+              <a:t>EduVision</a:t>
+            </a:r>
+            <a:endParaRPr lang="en-US" sz="1100" dirty="0"/>
+          </a:p>
+        </p:txBody>
+      </p:sp>
+      <p:sp>
+        <p:nvSpPr>
+          <p:cNvPr id="5" name="Text 3"/>
+          <p:cNvSpPr txBox="1"/>
+          <p:nvPr/>
+        </p:nvSpPr>
+        <p:spPr>
+          <a:xfrm>
+            <a:off x="8138160" y="4709160"/>
+            <a:ext cx="640080" cy="274320"/>
+          </a:xfrm>
+          <a:prstGeom prst="rect">
+            <a:avLst/>
+          </a:prstGeom>
+          <a:noFill/>
+          <a:ln/>
+        </p:spPr>
+        <p:txBody>
+          <a:bodyPr wrap="square" lIns="0" tIns="0" rIns="0" bIns="0" rtlCol="0" anchor="ctr"/>
+          <a:lstStyle/>
+          <a:p>
+            <a:pPr marL="0" indent="0" algn="r">
+              <a:buNone/>
+            </a:pPr>
+            <a:r>
+              <a:rPr lang="en-US" sz="1000" dirty="0">
+                <a:solidFill>
+                  <a:srgbClr val="F47B20"/>
+                </a:solidFill>
+                <a:latin typeface="Arial" pitchFamily="34" charset="0"/>
+                <a:ea typeface="Arial" pitchFamily="34" charset="-122"/>
+                <a:cs typeface="Arial" pitchFamily="34" charset="-120"/>
+              </a:rPr>
+              <a:t>17</a:t>
+            </a:r>
+            <a:endParaRPr lang="en-US" sz="1000" dirty="0"/>
+          </a:p>
+        </p:txBody>
+      </p:sp>
+      <p:sp>
+        <p:nvSpPr>
+          <p:cNvPr id="6" name="Text 4"/>
+          <p:cNvSpPr txBox="1"/>
+          <p:nvPr/>
+        </p:nvSpPr>
+        <p:spPr>
+          <a:xfrm>
+            <a:off x="457200" y="640080"/>
+            <a:ext cx="8229600" cy="640080"/>
+          </a:xfrm>
+          <a:prstGeom prst="rect">
+            <a:avLst/>
+          </a:prstGeom>
+          <a:noFill/>
+          <a:ln/>
+        </p:spPr>
+        <p:txBody>
+          <a:bodyPr wrap="square" lIns="0" tIns="0" rIns="0" bIns="0" rtlCol="0" anchor="ctr"/>
+          <a:lstStyle/>
+          <a:p>
+            <a:pPr marL="0" indent="0">
+              <a:buNone/>
+            </a:pPr>
+            <a:r>
+              <a:rPr lang="en-US" sz="2600" b="1" dirty="0">
+                <a:solidFill>
+                  <a:srgbClr val="E8442F"/>
+                </a:solidFill>
+                <a:latin typeface="Arial" pitchFamily="34" charset="0"/>
+                <a:ea typeface="Arial" pitchFamily="34" charset="-122"/>
+                <a:cs typeface="Arial" pitchFamily="34" charset="-120"/>
+              </a:rPr>
+              <a:t>Testing / Validation</a:t>
+            </a:r>
+            <a:endParaRPr lang="en-US" sz="2600" dirty="0"/>
+          </a:p>
+        </p:txBody>
+      </p:sp>
+      <p:sp>
+        <p:nvSpPr>
+          <p:cNvPr id="7" name="Shape 5"/>
+          <p:cNvSpPr/>
+          <p:nvPr/>
+        </p:nvSpPr>
+        <p:spPr>
+          <a:xfrm>
+            <a:off x="457200" y="1645920"/>
+            <a:ext cx="2590800" cy="1554480"/>
+          </a:xfrm>
+          <a:prstGeom prst="roundRect">
+            <a:avLst>
+              <a:gd name="adj" fmla="val 7059"/>
+            </a:avLst>
+          </a:prstGeom>
+          <a:solidFill>
+            <a:srgbClr val="FFF1E8"/>
+          </a:solidFill>
+          <a:ln w="12700">
+            <a:solidFill>
+              <a:srgbClr val="F47B20"/>
+            </a:solidFill>
+            <a:prstDash val="solid"/>
+          </a:ln>
+        </p:spPr>
+        <p:txBody>
+          <a:bodyPr/>
+          <a:p/>
+        </p:txBody>
+      </p:sp>
+      <p:sp>
+        <p:nvSpPr>
+          <p:cNvPr id="8" name="Text 6"/>
+          <p:cNvSpPr txBox="1"/>
+          <p:nvPr/>
+        </p:nvSpPr>
+        <p:spPr>
+          <a:xfrm>
+            <a:off x="457200" y="1828800"/>
+            <a:ext cx="2590800" cy="731520"/>
+          </a:xfrm>
+          <a:prstGeom prst="rect">
+            <a:avLst/>
+          </a:prstGeom>
+          <a:noFill/>
+          <a:ln/>
+        </p:spPr>
+        <p:txBody>
+          <a:bodyPr wrap="square" lIns="0" tIns="0" rIns="0" bIns="0" rtlCol="0" anchor="ctr"/>
+          <a:lstStyle/>
+          <a:p>
+            <a:pPr marL="0" indent="0" algn="ctr">
+              <a:buNone/>
+            </a:pPr>
+            <a:r>
+              <a:rPr lang="en-US" sz="3000" b="1" dirty="0">
+                <a:solidFill>
+                  <a:srgbClr val="E8442F"/>
+                </a:solidFill>
+                <a:latin typeface="Arial" pitchFamily="34" charset="0"/>
+                <a:ea typeface="Arial" pitchFamily="34" charset="-122"/>
+                <a:cs typeface="Arial" pitchFamily="34" charset="-120"/>
+              </a:rPr>
+              <a:t>6/6</a:t>
+            </a:r>
+            <a:endParaRPr lang="en-US" sz="3000" dirty="0"/>
+          </a:p>
+        </p:txBody>
+      </p:sp>
+      <p:sp>
+        <p:nvSpPr>
+          <p:cNvPr id="9" name="Text 7"/>
+          <p:cNvSpPr txBox="1"/>
+          <p:nvPr/>
+        </p:nvSpPr>
+        <p:spPr>
+          <a:xfrm>
+            <a:off x="548640" y="2560320"/>
+            <a:ext cx="2407920" cy="548640"/>
+          </a:xfrm>
+          <a:prstGeom prst="rect">
+            <a:avLst/>
+          </a:prstGeom>
+          <a:noFill/>
+          <a:ln/>
+        </p:spPr>
+        <p:txBody>
+          <a:bodyPr wrap="square" lIns="0" tIns="0" rIns="0" bIns="0" rtlCol="0" anchor="t"/>
+          <a:lstStyle/>
+          <a:p>
+            <a:pPr marL="0" indent="0" algn="ctr">
+              <a:buNone/>
+            </a:pPr>
+            <a:r>
+              <a:rPr lang="en-US" sz="1150" dirty="0">
+                <a:solidFill>
+                  <a:srgbClr val="3A2A2A"/>
+                </a:solidFill>
+                <a:latin typeface="Arial" pitchFamily="34" charset="0"/>
+                <a:ea typeface="Arial" pitchFamily="34" charset="-122"/>
+                <a:cs typeface="Arial" pitchFamily="34" charset="-120"/>
+              </a:rPr>
+              <a:t>KPIs validated</a:t>
+            </a:r>
+            <a:endParaRPr lang="en-US" sz="1150" dirty="0"/>
+          </a:p>
+        </p:txBody>
+      </p:sp>
+      <p:sp>
+        <p:nvSpPr>
+          <p:cNvPr id="10" name="Shape 8"/>
+          <p:cNvSpPr/>
+          <p:nvPr/>
+        </p:nvSpPr>
+        <p:spPr>
+          <a:xfrm>
+            <a:off x="3276600" y="1645920"/>
+            <a:ext cx="2590800" cy="1554480"/>
+          </a:xfrm>
+          <a:prstGeom prst="roundRect">
+            <a:avLst>
+              <a:gd name="adj" fmla="val 7059"/>
+            </a:avLst>
+          </a:prstGeom>
+          <a:solidFill>
+            <a:srgbClr val="FFF1E8"/>
+          </a:solidFill>
+          <a:ln w="12700">
+            <a:solidFill>
+              <a:srgbClr val="F47B20"/>
+            </a:solidFill>
+            <a:prstDash val="solid"/>
+          </a:ln>
+        </p:spPr>
+        <p:txBody>
+          <a:bodyPr/>
+          <a:p/>
+        </p:txBody>
+      </p:sp>
+      <p:sp>
+        <p:nvSpPr>
+          <p:cNvPr id="11" name="Text 9"/>
+          <p:cNvSpPr txBox="1"/>
+          <p:nvPr/>
+        </p:nvSpPr>
+        <p:spPr>
+          <a:xfrm>
+            <a:off x="3276600" y="1828800"/>
+            <a:ext cx="2590800" cy="731520"/>
+          </a:xfrm>
+          <a:prstGeom prst="rect">
+            <a:avLst/>
+          </a:prstGeom>
+          <a:noFill/>
+          <a:ln/>
+        </p:spPr>
+        <p:txBody>
+          <a:bodyPr wrap="square" lIns="0" tIns="0" rIns="0" bIns="0" rtlCol="0" anchor="ctr"/>
+          <a:lstStyle/>
+          <a:p>
+            <a:pPr marL="0" indent="0" algn="ctr">
+              <a:buNone/>
+            </a:pPr>
+            <a:r>
+              <a:rPr lang="en-US" sz="3000" b="1" dirty="0">
+                <a:solidFill>
+                  <a:srgbClr val="E8442F"/>
+                </a:solidFill>
+                <a:latin typeface="Arial" pitchFamily="34" charset="0"/>
+                <a:ea typeface="Arial" pitchFamily="34" charset="-122"/>
+                <a:cs typeface="Arial" pitchFamily="34" charset="-120"/>
+              </a:rPr>
+              <a:t>12/12</a:t>
+            </a:r>
+            <a:endParaRPr lang="en-US" sz="3000" dirty="0"/>
+          </a:p>
+        </p:txBody>
+      </p:sp>
+      <p:sp>
+        <p:nvSpPr>
+          <p:cNvPr id="12" name="Text 10"/>
+          <p:cNvSpPr txBox="1"/>
+          <p:nvPr/>
+        </p:nvSpPr>
+        <p:spPr>
+          <a:xfrm>
+            <a:off x="3368040" y="2560320"/>
+            <a:ext cx="2407920" cy="548640"/>
+          </a:xfrm>
+          <a:prstGeom prst="rect">
+            <a:avLst/>
+          </a:prstGeom>
+          <a:noFill/>
+          <a:ln/>
+        </p:spPr>
+        <p:txBody>
+          <a:bodyPr wrap="square" lIns="0" tIns="0" rIns="0" bIns="0" rtlCol="0" anchor="t"/>
+          <a:lstStyle/>
+          <a:p>
+            <a:pPr marL="0" indent="0" algn="ctr">
+              <a:buNone/>
+            </a:pPr>
+            <a:r>
+              <a:rPr lang="en-US" sz="1150" dirty="0">
+                <a:solidFill>
+                  <a:srgbClr val="3A2A2A"/>
+                </a:solidFill>
+                <a:latin typeface="Arial" pitchFamily="34" charset="0"/>
+                <a:ea typeface="Arial" pitchFamily="34" charset="-122"/>
+                <a:cs typeface="Arial" pitchFamily="34" charset="-120"/>
+              </a:rPr>
+              <a:t>interaction tests passed</a:t>
+            </a:r>
+            <a:endParaRPr lang="en-US" sz="1150" dirty="0"/>
+          </a:p>
+        </p:txBody>
+      </p:sp>
+      <p:sp>
+        <p:nvSpPr>
+          <p:cNvPr id="13" name="Shape 11"/>
+          <p:cNvSpPr/>
+          <p:nvPr/>
+        </p:nvSpPr>
+        <p:spPr>
+          <a:xfrm>
+            <a:off x="6096000" y="1645920"/>
+            <a:ext cx="2590800" cy="1554480"/>
+          </a:xfrm>
+          <a:prstGeom prst="roundRect">
+            <a:avLst>
+              <a:gd name="adj" fmla="val 7059"/>
+            </a:avLst>
+          </a:prstGeom>
+          <a:solidFill>
+            <a:srgbClr val="FFF1E8"/>
+          </a:solidFill>
+          <a:ln w="12700">
+            <a:solidFill>
+              <a:srgbClr val="F47B20"/>
+            </a:solidFill>
+            <a:prstDash val="solid"/>
+          </a:ln>
+        </p:spPr>
+        <p:txBody>
+          <a:bodyPr/>
+          <a:p/>
+        </p:txBody>
+      </p:sp>
+      <p:sp>
+        <p:nvSpPr>
+          <p:cNvPr id="14" name="Text 12"/>
+          <p:cNvSpPr txBox="1"/>
+          <p:nvPr/>
+        </p:nvSpPr>
+        <p:spPr>
+          <a:xfrm>
+            <a:off x="6096000" y="1828800"/>
+            <a:ext cx="2590800" cy="731520"/>
+          </a:xfrm>
+          <a:prstGeom prst="rect">
+            <a:avLst/>
+          </a:prstGeom>
+          <a:noFill/>
+          <a:ln/>
+        </p:spPr>
+        <p:txBody>
+          <a:bodyPr wrap="square" lIns="0" tIns="0" rIns="0" bIns="0" rtlCol="0" anchor="ctr"/>
+          <a:lstStyle/>
+          <a:p>
+            <a:pPr marL="0" indent="0" algn="ctr">
+              <a:buNone/>
+            </a:pPr>
+            <a:r>
+              <a:rPr lang="en-US" sz="3000" b="1" dirty="0">
+                <a:solidFill>
+                  <a:srgbClr val="E8442F"/>
+                </a:solidFill>
+                <a:latin typeface="Arial" pitchFamily="34" charset="0"/>
+                <a:ea typeface="Arial" pitchFamily="34" charset="-122"/>
+                <a:cs typeface="Arial" pitchFamily="34" charset="-120"/>
+              </a:rPr>
+              <a:t>42</a:t>
+            </a:r>
+            <a:endParaRPr lang="en-US" sz="3000" dirty="0"/>
+          </a:p>
+        </p:txBody>
+      </p:sp>
+      <p:sp>
+        <p:nvSpPr>
+          <p:cNvPr id="15" name="Text 13"/>
+          <p:cNvSpPr txBox="1"/>
+          <p:nvPr/>
+        </p:nvSpPr>
+        <p:spPr>
+          <a:xfrm>
+            <a:off x="6187440" y="2560320"/>
+            <a:ext cx="2407920" cy="548640"/>
+          </a:xfrm>
+          <a:prstGeom prst="rect">
+            <a:avLst/>
+          </a:prstGeom>
+          <a:noFill/>
+          <a:ln/>
+        </p:spPr>
+        <p:txBody>
+          <a:bodyPr wrap="square" lIns="0" tIns="0" rIns="0" bIns="0" rtlCol="0" anchor="t"/>
+          <a:lstStyle/>
+          <a:p>
+            <a:pPr marL="0" indent="0" algn="ctr">
+              <a:buNone/>
+            </a:pPr>
+            <a:r>
+              <a:rPr lang="en-US" sz="1150" dirty="0">
+                <a:solidFill>
+                  <a:srgbClr val="3A2A2A"/>
+                </a:solidFill>
+                <a:latin typeface="Arial" pitchFamily="34" charset="0"/>
+                <a:ea typeface="Arial" pitchFamily="34" charset="-122"/>
+                <a:cs typeface="Arial" pitchFamily="34" charset="-120"/>
+              </a:rPr>
+              <a:t>QA checks marked PASS</a:t>
+            </a:r>
+            <a:endParaRPr lang="en-US" sz="1150" dirty="0"/>
+          </a:p>
+        </p:txBody>
+      </p:sp>
+      <p:sp>
+        <p:nvSpPr>
+          <p:cNvPr id="16" name="Text 14"/>
+          <p:cNvSpPr txBox="1"/>
+          <p:nvPr/>
+        </p:nvSpPr>
+        <p:spPr>
+          <a:xfrm>
+            <a:off x="457200" y="3474720"/>
+            <a:ext cx="8229600" cy="1188720"/>
+          </a:xfrm>
+          <a:prstGeom prst="rect">
+            <a:avLst/>
+          </a:prstGeom>
+          <a:noFill/>
+          <a:ln/>
+        </p:spPr>
+        <p:txBody>
+          <a:bodyPr wrap="square" lIns="0" tIns="0" rIns="0" bIns="0" rtlCol="0" anchor="t"/>
+          <a:lstStyle/>
+          <a:p>
+            <a:pPr marL="342900" indent="-342900">
+              <a:spcAft>
+                <a:spcPts val="700"/>
+              </a:spcAft>
+              <a:buSzPct val="100000"/>
+              <a:buChar char="●"/>
+            </a:pPr>
+            <a:r>
+              <a:rPr lang="en-US" sz="1300" dirty="0">
+                <a:solidFill>
+                  <a:srgbClr val="3A2A2A"/>
+                </a:solidFill>
+                <a:latin typeface="Arial" pitchFamily="34" charset="0"/>
+                <a:ea typeface="Arial" pitchFamily="34" charset="-122"/>
+                <a:cs typeface="Arial" pitchFamily="34" charset="-120"/>
+              </a:rPr>
+              <a:t>Fixed country-code relationship, ranking sort and research field issues</a:t>
+            </a:r>
+            <a:endParaRPr lang="en-US" sz="1300" dirty="0"/>
+          </a:p>
+          <a:p>
+            <a:pPr marL="342900" indent="-342900">
+              <a:spcAft>
+                <a:spcPts val="700"/>
+              </a:spcAft>
+              <a:buSzPct val="100000"/>
+              <a:buChar char="●"/>
+            </a:pPr>
+            <a:r>
+              <a:rPr lang="en-US" sz="1300" dirty="0">
+                <a:solidFill>
+                  <a:srgbClr val="3A2A2A"/>
+                </a:solidFill>
+                <a:latin typeface="Arial" pitchFamily="34" charset="0"/>
+                <a:ea typeface="Arial" pitchFamily="34" charset="-122"/>
+                <a:cs typeface="Arial" pitchFamily="34" charset="-120"/>
+              </a:rPr>
+              <a:t>No duplicate or missing university IDs; row count preserved</a:t>
+            </a:r>
+            <a:endParaRPr lang="en-US" sz="1300" dirty="0"/>
+          </a:p>
+        </p:txBody>
+      </p:sp>
+    </p:spTree>
+  </p:cSld>
+  <p:clrMapOvr>
+    <a:masterClrMapping/>
+  </p:clrMapOvr>
+  <p:transition spd="med">
+    <p:cover dir="l"/>
   </p:transition>
 </p:sld>
 </file>
@@ -6710,6 +9154,10 @@
           </a:solidFill>
           <a:ln/>
         </p:spPr>
+        <p:txBody>
+          <a:bodyPr/>
+          <a:p/>
+        </p:txBody>
       </p:sp>
       <p:sp>
         <p:nvSpPr>
@@ -6730,6 +9178,10 @@
           </a:solidFill>
           <a:ln/>
         </p:spPr>
+        <p:txBody>
+          <a:bodyPr/>
+          <a:p/>
+        </p:txBody>
       </p:sp>
       <p:sp>
         <p:nvSpPr>
@@ -6876,6 +9328,10 @@
             </a:outerShdw>
           </a:effectLst>
         </p:spPr>
+        <p:txBody>
+          <a:bodyPr/>
+          <a:p/>
+        </p:txBody>
       </p:sp>
       <p:sp>
         <p:nvSpPr>
@@ -7022,6 +9478,10 @@
             </a:outerShdw>
           </a:effectLst>
         </p:spPr>
+        <p:txBody>
+          <a:bodyPr/>
+          <a:p/>
+        </p:txBody>
       </p:sp>
       <p:sp>
         <p:nvSpPr>
@@ -7168,6 +9628,10 @@
             </a:outerShdw>
           </a:effectLst>
         </p:spPr>
+        <p:txBody>
+          <a:bodyPr/>
+          <a:p/>
+        </p:txBody>
       </p:sp>
       <p:sp>
         <p:nvSpPr>
@@ -7314,6 +9778,10 @@
             </a:outerShdw>
           </a:effectLst>
         </p:spPr>
+        <p:txBody>
+          <a:bodyPr/>
+          <a:p/>
+        </p:txBody>
       </p:sp>
       <p:sp>
         <p:nvSpPr>
@@ -7489,6 +9957,10 @@
           </a:solidFill>
           <a:ln/>
         </p:spPr>
+        <p:txBody>
+          <a:bodyPr/>
+          <a:p/>
+        </p:txBody>
       </p:sp>
       <p:sp>
         <p:nvSpPr>
@@ -7509,6 +9981,10 @@
           </a:solidFill>
           <a:ln/>
         </p:spPr>
+        <p:txBody>
+          <a:bodyPr/>
+          <a:p/>
+        </p:txBody>
       </p:sp>
       <p:sp>
         <p:nvSpPr>
@@ -7754,6 +10230,10 @@
           </a:solidFill>
           <a:ln/>
         </p:spPr>
+        <p:txBody>
+          <a:bodyPr/>
+          <a:p/>
+        </p:txBody>
       </p:sp>
       <p:sp>
         <p:nvSpPr>
@@ -7815,6 +10295,10 @@
           </a:solidFill>
           <a:ln/>
         </p:spPr>
+        <p:txBody>
+          <a:bodyPr/>
+          <a:p/>
+        </p:txBody>
       </p:sp>
       <p:sp>
         <p:nvSpPr>
@@ -7876,6 +10360,10 @@
           </a:solidFill>
           <a:ln/>
         </p:spPr>
+        <p:txBody>
+          <a:bodyPr/>
+          <a:p/>
+        </p:txBody>
       </p:sp>
       <p:sp>
         <p:nvSpPr>
@@ -7937,6 +10425,10 @@
           </a:solidFill>
           <a:ln/>
         </p:spPr>
+        <p:txBody>
+          <a:bodyPr/>
+          <a:p/>
+        </p:txBody>
       </p:sp>
       <p:sp>
         <p:nvSpPr>
@@ -8034,6 +10526,10 @@
           </a:solidFill>
           <a:ln/>
         </p:spPr>
+        <p:txBody>
+          <a:bodyPr/>
+          <a:p/>
+        </p:txBody>
       </p:sp>
       <p:sp>
         <p:nvSpPr>
@@ -8054,6 +10550,10 @@
           </a:solidFill>
           <a:ln/>
         </p:spPr>
+        <p:txBody>
+          <a:bodyPr/>
+          <a:p/>
+        </p:txBody>
       </p:sp>
       <p:sp>
         <p:nvSpPr>
@@ -8200,6 +10700,10 @@
             </a:outerShdw>
           </a:effectLst>
         </p:spPr>
+        <p:txBody>
+          <a:bodyPr/>
+          <a:p/>
+        </p:txBody>
       </p:sp>
       <p:sp>
         <p:nvSpPr>
@@ -8346,6 +10850,10 @@
             </a:outerShdw>
           </a:effectLst>
         </p:spPr>
+        <p:txBody>
+          <a:bodyPr/>
+          <a:p/>
+        </p:txBody>
       </p:sp>
       <p:sp>
         <p:nvSpPr>
@@ -8492,6 +11000,10 @@
             </a:outerShdw>
           </a:effectLst>
         </p:spPr>
+        <p:txBody>
+          <a:bodyPr/>
+          <a:p/>
+        </p:txBody>
       </p:sp>
       <p:sp>
         <p:nvSpPr>
@@ -8638,6 +11150,10 @@
             </a:outerShdw>
           </a:effectLst>
         </p:spPr>
+        <p:txBody>
+          <a:bodyPr/>
+          <a:p/>
+        </p:txBody>
       </p:sp>
       <p:sp>
         <p:nvSpPr>
@@ -8813,6 +11329,10 @@
           </a:solidFill>
           <a:ln/>
         </p:spPr>
+        <p:txBody>
+          <a:bodyPr/>
+          <a:p/>
+        </p:txBody>
       </p:sp>
       <p:sp>
         <p:nvSpPr>
@@ -8833,6 +11353,10 @@
           </a:solidFill>
           <a:ln/>
         </p:spPr>
+        <p:txBody>
+          <a:bodyPr/>
+          <a:p/>
+        </p:txBody>
       </p:sp>
       <p:sp>
         <p:nvSpPr>
@@ -8979,6 +11503,10 @@
             </a:outerShdw>
           </a:effectLst>
         </p:spPr>
+        <p:txBody>
+          <a:bodyPr/>
+          <a:p/>
+        </p:txBody>
       </p:sp>
       <p:sp>
         <p:nvSpPr>
@@ -9125,6 +11653,10 @@
             </a:outerShdw>
           </a:effectLst>
         </p:spPr>
+        <p:txBody>
+          <a:bodyPr/>
+          <a:p/>
+        </p:txBody>
       </p:sp>
       <p:sp>
         <p:nvSpPr>
@@ -9271,6 +11803,10 @@
             </a:outerShdw>
           </a:effectLst>
         </p:spPr>
+        <p:txBody>
+          <a:bodyPr/>
+          <a:p/>
+        </p:txBody>
       </p:sp>
       <p:sp>
         <p:nvSpPr>
@@ -9417,6 +11953,10 @@
             </a:outerShdw>
           </a:effectLst>
         </p:spPr>
+        <p:txBody>
+          <a:bodyPr/>
+          <a:p/>
+        </p:txBody>
       </p:sp>
       <p:sp>
         <p:nvSpPr>
@@ -9592,6 +12132,10 @@
           </a:solidFill>
           <a:ln/>
         </p:spPr>
+        <p:txBody>
+          <a:bodyPr/>
+          <a:p/>
+        </p:txBody>
       </p:sp>
       <p:sp>
         <p:nvSpPr>
@@ -9612,6 +12156,10 @@
           </a:solidFill>
           <a:ln/>
         </p:spPr>
+        <p:txBody>
+          <a:bodyPr/>
+          <a:p/>
+        </p:txBody>
       </p:sp>
       <p:sp>
         <p:nvSpPr>
@@ -9751,6 +12299,10 @@
           </a:solidFill>
           <a:ln/>
         </p:spPr>
+        <p:txBody>
+          <a:bodyPr/>
+          <a:p/>
+        </p:txBody>
       </p:sp>
       <p:sp>
         <p:nvSpPr>
@@ -9851,6 +12403,10 @@
           </a:solidFill>
           <a:ln/>
         </p:spPr>
+        <p:txBody>
+          <a:bodyPr/>
+          <a:p/>
+        </p:txBody>
       </p:sp>
       <p:sp>
         <p:nvSpPr>
@@ -9951,6 +12507,10 @@
           </a:solidFill>
           <a:ln/>
         </p:spPr>
+        <p:txBody>
+          <a:bodyPr/>
+          <a:p/>
+        </p:txBody>
       </p:sp>
       <p:sp>
         <p:nvSpPr>
@@ -10051,6 +12611,10 @@
           </a:solidFill>
           <a:ln/>
         </p:spPr>
+        <p:txBody>
+          <a:bodyPr/>
+          <a:p/>
+        </p:txBody>
       </p:sp>
       <p:sp>
         <p:nvSpPr>
@@ -10151,6 +12715,10 @@
           </a:solidFill>
           <a:ln/>
         </p:spPr>
+        <p:txBody>
+          <a:bodyPr/>
+          <a:p/>
+        </p:txBody>
       </p:sp>
       <p:sp>
         <p:nvSpPr>
@@ -10212,6 +12780,10 @@
           </a:solidFill>
           <a:ln/>
         </p:spPr>
+        <p:txBody>
+          <a:bodyPr/>
+          <a:p/>
+        </p:txBody>
       </p:sp>
     </p:spTree>
   </p:cSld>
@@ -10270,6 +12842,10 @@
           </a:solidFill>
           <a:ln/>
         </p:spPr>
+        <p:txBody>
+          <a:bodyPr/>
+          <a:p/>
+        </p:txBody>
       </p:sp>
       <p:sp>
         <p:nvSpPr>
@@ -10290,6 +12866,10 @@
           </a:solidFill>
           <a:ln/>
         </p:spPr>
+        <p:txBody>
+          <a:bodyPr/>
+          <a:p/>
+        </p:txBody>
       </p:sp>
       <p:sp>
         <p:nvSpPr>
@@ -10582,6 +13162,10 @@
             <a:prstDash val="solid"/>
           </a:ln>
         </p:spPr>
+        <p:txBody>
+          <a:bodyPr/>
+          <a:p/>
+        </p:txBody>
       </p:sp>
       <p:sp>
         <p:nvSpPr>
@@ -10687,6 +13271,10 @@
             <a:prstDash val="solid"/>
           </a:ln>
         </p:spPr>
+        <p:txBody>
+          <a:bodyPr/>
+          <a:p/>
+        </p:txBody>
       </p:sp>
       <p:sp>
         <p:nvSpPr>
@@ -10823,6 +13411,10 @@
           </a:solidFill>
           <a:ln/>
         </p:spPr>
+        <p:txBody>
+          <a:bodyPr/>
+          <a:p/>
+        </p:txBody>
       </p:sp>
       <p:sp>
         <p:nvSpPr>
@@ -10843,6 +13435,10 @@
           </a:solidFill>
           <a:ln/>
         </p:spPr>
+        <p:txBody>
+          <a:bodyPr/>
+          <a:p/>
+        </p:txBody>
       </p:sp>
       <p:sp>
         <p:nvSpPr>
@@ -10982,6 +13578,10 @@
           </a:solidFill>
           <a:ln/>
         </p:spPr>
+        <p:txBody>
+          <a:bodyPr/>
+          <a:p/>
+        </p:txBody>
       </p:sp>
       <p:sp>
         <p:nvSpPr>
@@ -11060,6 +13660,10 @@
           </a:solidFill>
           <a:ln/>
         </p:spPr>
+        <p:txBody>
+          <a:bodyPr/>
+          <a:p/>
+        </p:txBody>
       </p:sp>
       <p:sp>
         <p:nvSpPr>
@@ -11122,6 +13726,10 @@
             <a:prstDash val="solid"/>
           </a:ln>
         </p:spPr>
+        <p:txBody>
+          <a:bodyPr/>
+          <a:p/>
+        </p:txBody>
       </p:sp>
       <p:sp>
         <p:nvSpPr>
@@ -11144,6 +13752,10 @@
           </a:solidFill>
           <a:ln/>
         </p:spPr>
+        <p:txBody>
+          <a:bodyPr/>
+          <a:p/>
+        </p:txBody>
       </p:sp>
       <p:sp>
         <p:nvSpPr>
@@ -11206,6 +13818,10 @@
             <a:prstDash val="solid"/>
           </a:ln>
         </p:spPr>
+        <p:txBody>
+          <a:bodyPr/>
+          <a:p/>
+        </p:txBody>
       </p:sp>
       <p:sp>
         <p:nvSpPr>
@@ -11228,6 +13844,10 @@
           </a:solidFill>
           <a:ln/>
         </p:spPr>
+        <p:txBody>
+          <a:bodyPr/>
+          <a:p/>
+        </p:txBody>
       </p:sp>
       <p:sp>
         <p:nvSpPr>
@@ -11290,6 +13910,10 @@
             <a:prstDash val="solid"/>
           </a:ln>
         </p:spPr>
+        <p:txBody>
+          <a:bodyPr/>
+          <a:p/>
+        </p:txBody>
       </p:sp>
       <p:sp>
         <p:nvSpPr>
@@ -11312,6 +13936,10 @@
           </a:solidFill>
           <a:ln/>
         </p:spPr>
+        <p:txBody>
+          <a:bodyPr/>
+          <a:p/>
+        </p:txBody>
       </p:sp>
       <p:sp>
         <p:nvSpPr>
@@ -11374,6 +14002,10 @@
             <a:prstDash val="solid"/>
           </a:ln>
         </p:spPr>
+        <p:txBody>
+          <a:bodyPr/>
+          <a:p/>
+        </p:txBody>
       </p:sp>
       <p:sp>
         <p:nvSpPr>
@@ -11397,6 +14029,10 @@
             <a:prstDash val="solid"/>
           </a:ln>
         </p:spPr>
+        <p:txBody>
+          <a:bodyPr/>
+          <a:p/>
+        </p:txBody>
       </p:sp>
       <p:sp>
         <p:nvSpPr>
@@ -11420,6 +14056,10 @@
             <a:prstDash val="solid"/>
           </a:ln>
         </p:spPr>
+        <p:txBody>
+          <a:bodyPr/>
+          <a:p/>
+        </p:txBody>
       </p:sp>
       <p:sp>
         <p:nvSpPr>
@@ -11443,6 +14083,10 @@
             <a:prstDash val="solid"/>
           </a:ln>
         </p:spPr>
+        <p:txBody>
+          <a:bodyPr/>
+          <a:p/>
+        </p:txBody>
       </p:sp>
       <p:sp>
         <p:nvSpPr>
@@ -11466,6 +14110,10 @@
             <a:prstDash val="solid"/>
           </a:ln>
         </p:spPr>
+        <p:txBody>
+          <a:bodyPr/>
+          <a:p/>
+        </p:txBody>
       </p:sp>
       <p:sp>
         <p:nvSpPr>
@@ -11488,6 +14136,10 @@
           </a:solidFill>
           <a:ln/>
         </p:spPr>
+        <p:txBody>
+          <a:bodyPr/>
+          <a:p/>
+        </p:txBody>
       </p:sp>
       <p:sp>
         <p:nvSpPr>
@@ -11567,6 +14219,10 @@
             <a:prstDash val="solid"/>
           </a:ln>
         </p:spPr>
+        <p:txBody>
+          <a:bodyPr/>
+          <a:p/>
+        </p:txBody>
       </p:sp>
     </p:spTree>
   </p:cSld>

</xml_diff>